<commit_message>
a ppt to introduce the solution of HybridClr hot reload.
</commit_message>
<xml_diff>
--- a/.codebuddy/ppt/热重载方案分享.pptx
+++ b/.codebuddy/ppt/热重载方案分享.pptx
@@ -24,9 +24,10 @@
     <p:sldId id="272" r:id="rId18"/>
     <p:sldId id="273" r:id="rId19"/>
     <p:sldId id="274" r:id="rId20"/>
+    <p:sldId id="275" r:id="rId21"/>
   </p:sldIdLst>
   <p:notesMasterIdLst>
-    <p:notesMasterId r:id="rId21"/>
+    <p:notesMasterId r:id="rId22"/>
   </p:notesMasterIdLst>
   <p:sldSz cx="12192000" cy="6858000"/>
   <p:notesSz cx="6858000" cy="12192000"/>
@@ -1530,6 +1531,94 @@
 </p:notes>
 </file>
 
+<file path=ppt/notesSlides/notesSlide20.xml><?xml version="1.0" encoding="utf-8"?>
+<p:notes xmlns:a="http://schemas.openxmlformats.org/drawingml/2006/main" xmlns:r="http://schemas.openxmlformats.org/officeDocument/2006/relationships" xmlns:p="http://schemas.openxmlformats.org/presentationml/2006/main">
+  <p:cSld>
+    <p:spTree>
+      <p:nvGrpSpPr>
+        <p:cNvPr id="1" name=""/>
+        <p:cNvGrpSpPr/>
+        <p:nvPr/>
+      </p:nvGrpSpPr>
+      <p:grpSpPr>
+        <a:xfrm>
+          <a:off x="0" y="0"/>
+          <a:ext cx="0" cy="0"/>
+          <a:chOff x="0" y="0"/>
+          <a:chExt cx="0" cy="0"/>
+        </a:xfrm>
+      </p:grpSpPr>
+      <p:sp>
+        <p:nvSpPr>
+          <p:cNvPr id="2" name="Slide Image Placeholder 1"/>
+          <p:cNvSpPr>
+            <a:spLocks noGrp="1" noRot="1" noChangeAspect="1"/>
+          </p:cNvSpPr>
+          <p:nvPr>
+            <p:ph type="sldImg"/>
+          </p:nvPr>
+        </p:nvSpPr>
+        <p:spPr/>
+      </p:sp>
+      <p:sp>
+        <p:nvSpPr>
+          <p:cNvPr id="3" name="Notes Placeholder 2"/>
+          <p:cNvSpPr>
+            <a:spLocks noGrp="1"/>
+          </p:cNvSpPr>
+          <p:nvPr>
+            <p:ph type="body" idx="1"/>
+          </p:nvPr>
+        </p:nvSpPr>
+        <p:spPr/>
+        <p:txBody>
+          <a:bodyPr/>
+          <a:lstStyle/>
+          <a:p>
+            <a:r>
+              <a:rPr lang="en-US" dirty="0"/>
+              <a:t/>
+            </a:r>
+            <a:endParaRPr lang="en-US" dirty="0"/>
+          </a:p>
+        </p:txBody>
+      </p:sp>
+      <p:sp>
+        <p:nvSpPr>
+          <p:cNvPr id="4" name="Slide Number Placeholder 3"/>
+          <p:cNvSpPr>
+            <a:spLocks noGrp="1"/>
+          </p:cNvSpPr>
+          <p:nvPr>
+            <p:ph type="sldNum" sz="quarter" idx="10"/>
+          </p:nvPr>
+        </p:nvSpPr>
+        <p:spPr/>
+        <p:txBody>
+          <a:bodyPr/>
+          <a:lstStyle/>
+          <a:p>
+            <a:fld id="{F7021451-1387-4CA6-816F-3879F97B5CBC}" type="slidenum">
+              <a:rPr lang="en-US"/>
+              <a:t>20</a:t>
+            </a:fld>
+            <a:endParaRPr lang="en-US"/>
+          </a:p>
+        </p:txBody>
+      </p:sp>
+    </p:spTree>
+    <p:extLst>
+      <p:ext uri="{BB962C8B-B14F-4D97-AF65-F5344CB8AC3E}">
+        <p14:creationId xmlns:p14="http://schemas.microsoft.com/office/powerpoint/2010/main" val="1024086991"/>
+      </p:ext>
+    </p:extLst>
+  </p:cSld>
+  <p:clrMapOvr>
+    <a:masterClrMapping/>
+  </p:clrMapOvr>
+</p:notes>
+</file>
+
 <file path=ppt/notesSlides/notesSlide3.xml><?xml version="1.0" encoding="utf-8"?>
 <p:notes xmlns:a="http://schemas.openxmlformats.org/drawingml/2006/main" xmlns:r="http://schemas.openxmlformats.org/officeDocument/2006/relationships" xmlns:p="http://schemas.openxmlformats.org/presentationml/2006/main">
   <p:cSld>
@@ -9464,7 +9553,7 @@
                 <a:ea typeface="Microsoft YaHei" pitchFamily="34" charset="-122"/>
                 <a:cs typeface="Microsoft YaHei" pitchFamily="34" charset="-120"/>
               </a:rPr>
-              <a:t>Takeaways</a:t>
+              <a:t>如何使用</a:t>
             </a:r>
             <a:endParaRPr lang="en-US" sz="1200" dirty="0"/>
           </a:p>
@@ -9503,7 +9592,7 @@
                 <a:ea typeface="Microsoft YaHei" pitchFamily="34" charset="-122"/>
                 <a:cs typeface="Microsoft YaHei" pitchFamily="34" charset="-120"/>
               </a:rPr>
-              <a:t>经验总结</a:t>
+              <a:t>工程使用方法：三步接入</a:t>
             </a:r>
             <a:endParaRPr lang="en-US" sz="2800" dirty="0"/>
           </a:p>
@@ -9556,8 +9645,8 @@
         </p:nvSpPr>
         <p:spPr>
           <a:xfrm>
-            <a:off x="502920" y="1371600"/>
-            <a:ext cx="5486400" cy="1463040"/>
+            <a:off x="502920" y="1463040"/>
+            <a:ext cx="3611880" cy="3291840"/>
           </a:xfrm>
           <a:prstGeom prst="rect">
             <a:avLst/>
@@ -9588,10 +9677,162 @@
         </p:nvSpPr>
         <p:spPr>
           <a:xfrm>
-            <a:off x="667512" y="1536192"/>
-            <a:ext cx="475488" cy="475488"/>
-          </a:xfrm>
-          <a:prstGeom prst="ellipse">
+            <a:off x="502920" y="1463040"/>
+            <a:ext cx="3611880" cy="530352"/>
+          </a:xfrm>
+          <a:prstGeom prst="rect">
+            <a:avLst/>
+          </a:prstGeom>
+          <a:solidFill>
+            <a:srgbClr val="0B7E89"/>
+          </a:solidFill>
+          <a:ln/>
+        </p:spPr>
+      </p:sp>
+      <p:sp>
+        <p:nvSpPr>
+          <p:cNvPr id="8" name="Text 6"/>
+          <p:cNvSpPr/>
+          <p:nvPr/>
+        </p:nvSpPr>
+        <p:spPr>
+          <a:xfrm>
+            <a:off x="640080" y="1463040"/>
+            <a:ext cx="3337560" cy="530352"/>
+          </a:xfrm>
+          <a:prstGeom prst="rect">
+            <a:avLst/>
+          </a:prstGeom>
+          <a:noFill/>
+          <a:ln/>
+        </p:spPr>
+        <p:txBody>
+          <a:bodyPr wrap="square" lIns="0" tIns="0" rIns="0" bIns="0" rtlCol="0" anchor="ctr"/>
+          <a:lstStyle/>
+          <a:p>
+            <a:pPr indent="0" marL="0">
+              <a:buNone/>
+            </a:pPr>
+            <a:r>
+              <a:rPr lang="en-US" sz="1450" b="1" dirty="0">
+                <a:solidFill>
+                  <a:srgbClr val="FFFFFF"/>
+                </a:solidFill>
+                <a:latin typeface="Microsoft YaHei" pitchFamily="34" charset="0"/>
+                <a:ea typeface="Microsoft YaHei" pitchFamily="34" charset="-122"/>
+                <a:cs typeface="Microsoft YaHei" pitchFamily="34" charset="-120"/>
+              </a:rPr>
+              <a:t>STEP 1   Install</a:t>
+            </a:r>
+            <a:endParaRPr lang="en-US" sz="1450" dirty="0"/>
+          </a:p>
+        </p:txBody>
+      </p:sp>
+      <p:sp>
+        <p:nvSpPr>
+          <p:cNvPr id="9" name="Text 7"/>
+          <p:cNvSpPr/>
+          <p:nvPr/>
+        </p:nvSpPr>
+        <p:spPr>
+          <a:xfrm>
+            <a:off x="667512" y="2121408"/>
+            <a:ext cx="3282696" cy="2468880"/>
+          </a:xfrm>
+          <a:prstGeom prst="rect">
+            <a:avLst/>
+          </a:prstGeom>
+          <a:noFill/>
+          <a:ln/>
+        </p:spPr>
+        <p:txBody>
+          <a:bodyPr wrap="square" lIns="0" tIns="0" rIns="0" bIns="0" rtlCol="0" anchor="t"/>
+          <a:lstStyle/>
+          <a:p>
+            <a:pPr indent="0" marL="0">
+              <a:spcAft>
+                <a:spcPts val="800"/>
+              </a:spcAft>
+              <a:buNone/>
+            </a:pPr>
+            <a:r>
+              <a:rPr lang="en-US" sz="1250" b="1" dirty="0">
+                <a:solidFill>
+                  <a:srgbClr val="16233B"/>
+                </a:solidFill>
+                <a:latin typeface="Microsoft YaHei" pitchFamily="34" charset="0"/>
+                <a:ea typeface="Microsoft YaHei" pitchFamily="34" charset="-122"/>
+                <a:cs typeface="Microsoft YaHei" pitchFamily="34" charset="-120"/>
+              </a:rPr>
+              <a:t>Unity 编辑器中使用正常的 HybridCLR 菜单执行 Install</a:t>
+            </a:r>
+            <a:endParaRPr lang="en-US" sz="1250" dirty="0"/>
+          </a:p>
+          <a:p>
+            <a:pPr indent="0" marL="0">
+              <a:buNone/>
+            </a:pPr>
+            <a:r>
+              <a:rPr lang="en-US" sz="1100" dirty="0">
+                <a:solidFill>
+                  <a:srgbClr val="63748A"/>
+                </a:solidFill>
+                <a:latin typeface="Microsoft YaHei" pitchFamily="34" charset="0"/>
+                <a:ea typeface="Microsoft YaHei" pitchFamily="34" charset="-122"/>
+                <a:cs typeface="Microsoft YaHei" pitchFamily="34" charset="-120"/>
+              </a:rPr>
+              <a:t>HybridCLR/Installer 菜单安装后，会在项目下生成改造过的 il2cpp 库目录：</a:t>
+            </a:r>
+            <a:endParaRPr lang="en-US" sz="1250" dirty="0"/>
+          </a:p>
+          <a:p>
+            <a:pPr indent="0" marL="0">
+              <a:buNone/>
+            </a:pPr>
+            <a:r>
+              <a:rPr lang="en-US" sz="1100" dirty="0">
+                <a:solidFill>
+                  <a:srgbClr val="63748A"/>
+                </a:solidFill>
+                <a:latin typeface="Microsoft YaHei" pitchFamily="34" charset="0"/>
+                <a:ea typeface="Microsoft YaHei" pitchFamily="34" charset="-122"/>
+                <a:cs typeface="Microsoft YaHei" pitchFamily="34" charset="-120"/>
+              </a:rPr>
+              <a:t>HybridCLRData\</a:t>
+            </a:r>
+            <a:endParaRPr lang="en-US" sz="1250" dirty="0"/>
+          </a:p>
+          <a:p>
+            <a:pPr indent="0" marL="0">
+              <a:buNone/>
+            </a:pPr>
+            <a:r>
+              <a:rPr lang="en-US" sz="1100" dirty="0">
+                <a:solidFill>
+                  <a:srgbClr val="63748A"/>
+                </a:solidFill>
+                <a:latin typeface="Microsoft YaHei" pitchFamily="34" charset="0"/>
+                <a:ea typeface="Microsoft YaHei" pitchFamily="34" charset="-122"/>
+                <a:cs typeface="Microsoft YaHei" pitchFamily="34" charset="-120"/>
+              </a:rPr>
+              <a:t>LocalIl2CppData-{Runtime}\</a:t>
+            </a:r>
+            <a:endParaRPr lang="en-US" sz="1250" dirty="0"/>
+          </a:p>
+        </p:txBody>
+      </p:sp>
+      <p:sp>
+        <p:nvSpPr>
+          <p:cNvPr id="10" name="Shape 8"/>
+          <p:cNvSpPr/>
+          <p:nvPr/>
+        </p:nvSpPr>
+        <p:spPr>
+          <a:xfrm>
+            <a:off x="4142232" y="2999232"/>
+            <a:ext cx="182880" cy="219456"/>
+          </a:xfrm>
+          <a:prstGeom prst="rightArrow">
             <a:avLst/>
           </a:prstGeom>
           <a:solidFill>
@@ -9602,109 +9843,14 @@
       </p:sp>
       <p:sp>
         <p:nvSpPr>
-          <p:cNvPr id="8" name="Text 6"/>
-          <p:cNvSpPr/>
-          <p:nvPr/>
-        </p:nvSpPr>
-        <p:spPr>
-          <a:xfrm>
-            <a:off x="667512" y="1536192"/>
-            <a:ext cx="475488" cy="475488"/>
-          </a:xfrm>
-          <a:prstGeom prst="rect">
-            <a:avLst/>
-          </a:prstGeom>
-          <a:noFill/>
-          <a:ln/>
-        </p:spPr>
-        <p:txBody>
-          <a:bodyPr wrap="square" lIns="0" tIns="0" rIns="0" bIns="0" rtlCol="0" anchor="ctr"/>
-          <a:lstStyle/>
-          <a:p>
-            <a:pPr algn="ctr" indent="0" marL="0">
-              <a:buNone/>
-            </a:pPr>
-            <a:r>
-              <a:rPr lang="en-US" sz="1600" b="1" dirty="0">
-                <a:solidFill>
-                  <a:srgbClr val="FFFFFF"/>
-                </a:solidFill>
-                <a:latin typeface="Microsoft YaHei" pitchFamily="34" charset="0"/>
-                <a:ea typeface="Microsoft YaHei" pitchFamily="34" charset="-122"/>
-                <a:cs typeface="Microsoft YaHei" pitchFamily="34" charset="-120"/>
-              </a:rPr>
-              <a:t>1</a:t>
-            </a:r>
-            <a:endParaRPr lang="en-US" sz="1600" dirty="0"/>
-          </a:p>
-        </p:txBody>
-      </p:sp>
-      <p:sp>
-        <p:nvSpPr>
-          <p:cNvPr id="9" name="Text 7"/>
-          <p:cNvSpPr/>
-          <p:nvPr/>
-        </p:nvSpPr>
-        <p:spPr>
-          <a:xfrm>
-            <a:off x="1307592" y="1499616"/>
-            <a:ext cx="4572000" cy="1234440"/>
-          </a:xfrm>
-          <a:prstGeom prst="rect">
-            <a:avLst/>
-          </a:prstGeom>
-          <a:noFill/>
-          <a:ln/>
-        </p:spPr>
-        <p:txBody>
-          <a:bodyPr wrap="square" lIns="0" tIns="0" rIns="0" bIns="0" rtlCol="0" anchor="t"/>
-          <a:lstStyle/>
-          <a:p>
-            <a:pPr indent="0" marL="0">
-              <a:buNone/>
-            </a:pPr>
-            <a:r>
-              <a:rPr lang="en-US" sz="1400" b="1" dirty="0">
-                <a:solidFill>
-                  <a:srgbClr val="16233B"/>
-                </a:solidFill>
-                <a:latin typeface="Microsoft YaHei" pitchFamily="34" charset="0"/>
-                <a:ea typeface="Microsoft YaHei" pitchFamily="34" charset="-122"/>
-                <a:cs typeface="Microsoft YaHei" pitchFamily="34" charset="-120"/>
-              </a:rPr>
-              <a:t>指针即身份</a:t>
-            </a:r>
-            <a:endParaRPr lang="en-US" sz="1400" dirty="0"/>
-          </a:p>
-          <a:p>
-            <a:pPr indent="0" marL="0">
-              <a:buNone/>
-            </a:pPr>
-            <a:r>
-              <a:rPr lang="en-US" sz="1100" dirty="0">
-                <a:solidFill>
-                  <a:srgbClr val="63748A"/>
-                </a:solidFill>
-                <a:latin typeface="Microsoft YaHei" pitchFamily="34" charset="0"/>
-                <a:ea typeface="Microsoft YaHei" pitchFamily="34" charset="-122"/>
-                <a:cs typeface="Microsoft YaHei" pitchFamily="34" charset="-120"/>
-              </a:rPr>
-              <a:t>Unity 层 / API 层 / 托管层三层一致约束，只有复用能同时满足；同型两指针必然身份分裂</a:t>
-            </a:r>
-            <a:endParaRPr lang="en-US" sz="1400" dirty="0"/>
-          </a:p>
-        </p:txBody>
-      </p:sp>
-      <p:sp>
-        <p:nvSpPr>
-          <p:cNvPr id="10" name="Shape 8"/>
-          <p:cNvSpPr/>
-          <p:nvPr/>
-        </p:nvSpPr>
-        <p:spPr>
-          <a:xfrm>
-            <a:off x="6309360" y="1371600"/>
-            <a:ext cx="5486400" cy="1463040"/>
+          <p:cNvPr id="11" name="Shape 9"/>
+          <p:cNvSpPr/>
+          <p:nvPr/>
+        </p:nvSpPr>
+        <p:spPr>
+          <a:xfrm>
+            <a:off x="4343400" y="1463040"/>
+            <a:ext cx="3611880" cy="3291840"/>
           </a:xfrm>
           <a:prstGeom prst="rect">
             <a:avLst/>
@@ -9729,16 +9875,151 @@
       </p:sp>
       <p:sp>
         <p:nvSpPr>
-          <p:cNvPr id="11" name="Shape 9"/>
-          <p:cNvSpPr/>
-          <p:nvPr/>
-        </p:nvSpPr>
-        <p:spPr>
-          <a:xfrm>
-            <a:off x="6473952" y="1536192"/>
-            <a:ext cx="475488" cy="475488"/>
-          </a:xfrm>
-          <a:prstGeom prst="ellipse">
+          <p:cNvPr id="12" name="Shape 10"/>
+          <p:cNvSpPr/>
+          <p:nvPr/>
+        </p:nvSpPr>
+        <p:spPr>
+          <a:xfrm>
+            <a:off x="4343400" y="1463040"/>
+            <a:ext cx="3611880" cy="530352"/>
+          </a:xfrm>
+          <a:prstGeom prst="rect">
+            <a:avLst/>
+          </a:prstGeom>
+          <a:solidFill>
+            <a:srgbClr val="20344F"/>
+          </a:solidFill>
+          <a:ln/>
+        </p:spPr>
+      </p:sp>
+      <p:sp>
+        <p:nvSpPr>
+          <p:cNvPr id="13" name="Text 11"/>
+          <p:cNvSpPr/>
+          <p:nvPr/>
+        </p:nvSpPr>
+        <p:spPr>
+          <a:xfrm>
+            <a:off x="4480560" y="1463040"/>
+            <a:ext cx="3337560" cy="530352"/>
+          </a:xfrm>
+          <a:prstGeom prst="rect">
+            <a:avLst/>
+          </a:prstGeom>
+          <a:noFill/>
+          <a:ln/>
+        </p:spPr>
+        <p:txBody>
+          <a:bodyPr wrap="square" lIns="0" tIns="0" rIns="0" bIns="0" rtlCol="0" anchor="ctr"/>
+          <a:lstStyle/>
+          <a:p>
+            <a:pPr indent="0" marL="0">
+              <a:buNone/>
+            </a:pPr>
+            <a:r>
+              <a:rPr lang="en-US" sz="1450" b="1" dirty="0">
+                <a:solidFill>
+                  <a:srgbClr val="FFFFFF"/>
+                </a:solidFill>
+                <a:latin typeface="Microsoft YaHei" pitchFamily="34" charset="0"/>
+                <a:ea typeface="Microsoft YaHei" pitchFamily="34" charset="-122"/>
+                <a:cs typeface="Microsoft YaHei" pitchFamily="34" charset="-120"/>
+              </a:rPr>
+              <a:t>STEP 2   替换</a:t>
+            </a:r>
+            <a:endParaRPr lang="en-US" sz="1450" dirty="0"/>
+          </a:p>
+        </p:txBody>
+      </p:sp>
+      <p:sp>
+        <p:nvSpPr>
+          <p:cNvPr id="14" name="Text 12"/>
+          <p:cNvSpPr/>
+          <p:nvPr/>
+        </p:nvSpPr>
+        <p:spPr>
+          <a:xfrm>
+            <a:off x="4507992" y="2121408"/>
+            <a:ext cx="3282696" cy="2468880"/>
+          </a:xfrm>
+          <a:prstGeom prst="rect">
+            <a:avLst/>
+          </a:prstGeom>
+          <a:noFill/>
+          <a:ln/>
+        </p:spPr>
+        <p:txBody>
+          <a:bodyPr wrap="square" lIns="0" tIns="0" rIns="0" bIns="0" rtlCol="0" anchor="t"/>
+          <a:lstStyle/>
+          <a:p>
+            <a:pPr indent="0" marL="0">
+              <a:spcAft>
+                <a:spcPts val="800"/>
+              </a:spcAft>
+              <a:buNone/>
+            </a:pPr>
+            <a:r>
+              <a:rPr lang="en-US" sz="1250" b="1" dirty="0">
+                <a:solidFill>
+                  <a:srgbClr val="16233B"/>
+                </a:solidFill>
+                <a:latin typeface="Microsoft YaHei" pitchFamily="34" charset="0"/>
+                <a:ea typeface="Microsoft YaHei" pitchFamily="34" charset="-122"/>
+                <a:cs typeface="Microsoft YaHei" pitchFamily="34" charset="-120"/>
+              </a:rPr>
+              <a:t>把该目录下的 il2cpp 库内容替换成本 git 库内容即可</a:t>
+            </a:r>
+            <a:endParaRPr lang="en-US" sz="1250" dirty="0"/>
+          </a:p>
+          <a:p>
+            <a:pPr indent="0" marL="0">
+              <a:buNone/>
+            </a:pPr>
+            <a:r>
+              <a:rPr lang="en-US" sz="1100" dirty="0">
+                <a:solidFill>
+                  <a:srgbClr val="63748A"/>
+                </a:solidFill>
+                <a:latin typeface="Microsoft YaHei" pitchFamily="34" charset="0"/>
+                <a:ea typeface="Microsoft YaHei" pitchFamily="34" charset="-122"/>
+                <a:cs typeface="Microsoft YaHei" pitchFamily="34" charset="-120"/>
+              </a:rPr>
+              <a:t>本仓库 = HybridCLR 官方 libil2cpp + 热重载改造（指针复用 / 二次加载 / vtable 混合布局）</a:t>
+            </a:r>
+            <a:endParaRPr lang="en-US" sz="1250" dirty="0"/>
+          </a:p>
+          <a:p>
+            <a:pPr indent="0" marL="0">
+              <a:buNone/>
+            </a:pPr>
+            <a:r>
+              <a:rPr lang="en-US" sz="1100" dirty="0">
+                <a:solidFill>
+                  <a:srgbClr val="63748A"/>
+                </a:solidFill>
+                <a:latin typeface="Microsoft YaHei" pitchFamily="34" charset="0"/>
+                <a:ea typeface="Microsoft YaHei" pitchFamily="34" charset="-122"/>
+                <a:cs typeface="Microsoft YaHei" pitchFamily="34" charset="-120"/>
+              </a:rPr>
+              <a:t>替换后重新构建 GameAssembly 生效</a:t>
+            </a:r>
+            <a:endParaRPr lang="en-US" sz="1250" dirty="0"/>
+          </a:p>
+        </p:txBody>
+      </p:sp>
+      <p:sp>
+        <p:nvSpPr>
+          <p:cNvPr id="15" name="Shape 13"/>
+          <p:cNvSpPr/>
+          <p:nvPr/>
+        </p:nvSpPr>
+        <p:spPr>
+          <a:xfrm>
+            <a:off x="7982712" y="2999232"/>
+            <a:ext cx="182880" cy="219456"/>
+          </a:xfrm>
+          <a:prstGeom prst="rightArrow">
             <a:avLst/>
           </a:prstGeom>
           <a:solidFill>
@@ -9749,109 +10030,14 @@
       </p:sp>
       <p:sp>
         <p:nvSpPr>
-          <p:cNvPr id="12" name="Text 10"/>
-          <p:cNvSpPr/>
-          <p:nvPr/>
-        </p:nvSpPr>
-        <p:spPr>
-          <a:xfrm>
-            <a:off x="6473952" y="1536192"/>
-            <a:ext cx="475488" cy="475488"/>
-          </a:xfrm>
-          <a:prstGeom prst="rect">
-            <a:avLst/>
-          </a:prstGeom>
-          <a:noFill/>
-          <a:ln/>
-        </p:spPr>
-        <p:txBody>
-          <a:bodyPr wrap="square" lIns="0" tIns="0" rIns="0" bIns="0" rtlCol="0" anchor="ctr"/>
-          <a:lstStyle/>
-          <a:p>
-            <a:pPr algn="ctr" indent="0" marL="0">
-              <a:buNone/>
-            </a:pPr>
-            <a:r>
-              <a:rPr lang="en-US" sz="1600" b="1" dirty="0">
-                <a:solidFill>
-                  <a:srgbClr val="FFFFFF"/>
-                </a:solidFill>
-                <a:latin typeface="Microsoft YaHei" pitchFamily="34" charset="0"/>
-                <a:ea typeface="Microsoft YaHei" pitchFamily="34" charset="-122"/>
-                <a:cs typeface="Microsoft YaHei" pitchFamily="34" charset="-120"/>
-              </a:rPr>
-              <a:t>2</a:t>
-            </a:r>
-            <a:endParaRPr lang="en-US" sz="1600" dirty="0"/>
-          </a:p>
-        </p:txBody>
-      </p:sp>
-      <p:sp>
-        <p:nvSpPr>
-          <p:cNvPr id="13" name="Text 11"/>
-          <p:cNvSpPr/>
-          <p:nvPr/>
-        </p:nvSpPr>
-        <p:spPr>
-          <a:xfrm>
-            <a:off x="7114032" y="1499616"/>
-            <a:ext cx="4572000" cy="1234440"/>
-          </a:xfrm>
-          <a:prstGeom prst="rect">
-            <a:avLst/>
-          </a:prstGeom>
-          <a:noFill/>
-          <a:ln/>
-        </p:spPr>
-        <p:txBody>
-          <a:bodyPr wrap="square" lIns="0" tIns="0" rIns="0" bIns="0" rtlCol="0" anchor="t"/>
-          <a:lstStyle/>
-          <a:p>
-            <a:pPr indent="0" marL="0">
-              <a:buNone/>
-            </a:pPr>
-            <a:r>
-              <a:rPr lang="en-US" sz="1400" b="1" dirty="0">
-                <a:solidFill>
-                  <a:srgbClr val="16233B"/>
-                </a:solidFill>
-                <a:latin typeface="Microsoft YaHei" pitchFamily="34" charset="0"/>
-                <a:ea typeface="Microsoft YaHei" pitchFamily="34" charset="-122"/>
-                <a:cs typeface="Microsoft YaHei" pitchFamily="34" charset="-120"/>
-              </a:rPr>
-              <a:t>缓存即雷区</a:t>
-            </a:r>
-            <a:endParaRPr lang="en-US" sz="1400" dirty="0"/>
-          </a:p>
-          <a:p>
-            <a:pPr indent="0" marL="0">
-              <a:buNone/>
-            </a:pPr>
-            <a:r>
-              <a:rPr lang="en-US" sz="1100" dirty="0">
-                <a:solidFill>
-                  <a:srgbClr val="63748A"/>
-                </a:solidFill>
-                <a:latin typeface="Microsoft YaHei" pitchFamily="34" charset="0"/>
-                <a:ea typeface="Microsoft YaHei" pitchFamily="34" charset="-122"/>
-                <a:cs typeface="Microsoft YaHei" pitchFamily="34" charset="-120"/>
-              </a:rPr>
-              <a:t>凡按裸指针 hash / 键控的缓存（泛型实例、TypeMap、MethodMap），重载后必须 rehash 或失效</a:t>
-            </a:r>
-            <a:endParaRPr lang="en-US" sz="1400" dirty="0"/>
-          </a:p>
-        </p:txBody>
-      </p:sp>
-      <p:sp>
-        <p:nvSpPr>
-          <p:cNvPr id="14" name="Shape 12"/>
-          <p:cNvSpPr/>
-          <p:nvPr/>
-        </p:nvSpPr>
-        <p:spPr>
-          <a:xfrm>
-            <a:off x="502920" y="2999232"/>
-            <a:ext cx="5486400" cy="1463040"/>
+          <p:cNvPr id="16" name="Shape 14"/>
+          <p:cNvSpPr/>
+          <p:nvPr/>
+        </p:nvSpPr>
+        <p:spPr>
+          <a:xfrm>
+            <a:off x="8183880" y="1463040"/>
+            <a:ext cx="3611880" cy="3291840"/>
           </a:xfrm>
           <a:prstGeom prst="rect">
             <a:avLst/>
@@ -9876,34 +10062,34 @@
       </p:sp>
       <p:sp>
         <p:nvSpPr>
-          <p:cNvPr id="15" name="Shape 13"/>
-          <p:cNvSpPr/>
-          <p:nvPr/>
-        </p:nvSpPr>
-        <p:spPr>
-          <a:xfrm>
-            <a:off x="667512" y="3163824"/>
-            <a:ext cx="475488" cy="475488"/>
-          </a:xfrm>
-          <a:prstGeom prst="ellipse">
-            <a:avLst/>
-          </a:prstGeom>
-          <a:solidFill>
-            <a:srgbClr val="0E9AA8"/>
-          </a:solidFill>
-          <a:ln/>
-        </p:spPr>
-      </p:sp>
-      <p:sp>
-        <p:nvSpPr>
-          <p:cNvPr id="16" name="Text 14"/>
-          <p:cNvSpPr/>
-          <p:nvPr/>
-        </p:nvSpPr>
-        <p:spPr>
-          <a:xfrm>
-            <a:off x="667512" y="3163824"/>
-            <a:ext cx="475488" cy="475488"/>
+          <p:cNvPr id="17" name="Shape 15"/>
+          <p:cNvSpPr/>
+          <p:nvPr/>
+        </p:nvSpPr>
+        <p:spPr>
+          <a:xfrm>
+            <a:off x="8183880" y="1463040"/>
+            <a:ext cx="3611880" cy="530352"/>
+          </a:xfrm>
+          <a:prstGeom prst="rect">
+            <a:avLst/>
+          </a:prstGeom>
+          <a:solidFill>
+            <a:srgbClr val="0B7E89"/>
+          </a:solidFill>
+          <a:ln/>
+        </p:spPr>
+      </p:sp>
+      <p:sp>
+        <p:nvSpPr>
+          <p:cNvPr id="18" name="Text 16"/>
+          <p:cNvSpPr/>
+          <p:nvPr/>
+        </p:nvSpPr>
+        <p:spPr>
+          <a:xfrm>
+            <a:off x="8321040" y="1463040"/>
+            <a:ext cx="3337560" cy="530352"/>
           </a:xfrm>
           <a:prstGeom prst="rect">
             <a:avLst/>
@@ -9915,11 +10101,11 @@
           <a:bodyPr wrap="square" lIns="0" tIns="0" rIns="0" bIns="0" rtlCol="0" anchor="ctr"/>
           <a:lstStyle/>
           <a:p>
-            <a:pPr algn="ctr" indent="0" marL="0">
-              <a:buNone/>
-            </a:pPr>
-            <a:r>
-              <a:rPr lang="en-US" sz="1600" b="1" dirty="0">
+            <a:pPr indent="0" marL="0">
+              <a:buNone/>
+            </a:pPr>
+            <a:r>
+              <a:rPr lang="en-US" sz="1450" b="1" dirty="0">
                 <a:solidFill>
                   <a:srgbClr val="FFFFFF"/>
                 </a:solidFill>
@@ -9927,22 +10113,22 @@
                 <a:ea typeface="Microsoft YaHei" pitchFamily="34" charset="-122"/>
                 <a:cs typeface="Microsoft YaHei" pitchFamily="34" charset="-120"/>
               </a:rPr>
-              <a:t>3</a:t>
-            </a:r>
-            <a:endParaRPr lang="en-US" sz="1600" dirty="0"/>
-          </a:p>
-        </p:txBody>
-      </p:sp>
-      <p:sp>
-        <p:nvSpPr>
-          <p:cNvPr id="17" name="Text 15"/>
-          <p:cNvSpPr/>
-          <p:nvPr/>
-        </p:nvSpPr>
-        <p:spPr>
-          <a:xfrm>
-            <a:off x="1307592" y="3127248"/>
-            <a:ext cx="4572000" cy="1234440"/>
+              <a:t>STEP 3   使用</a:t>
+            </a:r>
+            <a:endParaRPr lang="en-US" sz="1450" dirty="0"/>
+          </a:p>
+        </p:txBody>
+      </p:sp>
+      <p:sp>
+        <p:nvSpPr>
+          <p:cNvPr id="19" name="Text 17"/>
+          <p:cNvSpPr/>
+          <p:nvPr/>
+        </p:nvSpPr>
+        <p:spPr>
+          <a:xfrm>
+            <a:off x="8348472" y="2121408"/>
+            <a:ext cx="3282696" cy="2468880"/>
           </a:xfrm>
           <a:prstGeom prst="rect">
             <a:avLst/>
@@ -9955,10 +10141,13 @@
           <a:lstStyle/>
           <a:p>
             <a:pPr indent="0" marL="0">
-              <a:buNone/>
-            </a:pPr>
-            <a:r>
-              <a:rPr lang="en-US" sz="1400" b="1" dirty="0">
+              <a:spcAft>
+                <a:spcPts val="800"/>
+              </a:spcAft>
+              <a:buNone/>
+            </a:pPr>
+            <a:r>
+              <a:rPr lang="en-US" sz="1250" b="1" dirty="0">
                 <a:solidFill>
                   <a:srgbClr val="16233B"/>
                 </a:solidFill>
@@ -9966,9 +10155,9 @@
                 <a:ea typeface="Microsoft YaHei" pitchFamily="34" charset="-122"/>
                 <a:cs typeface="Microsoft YaHei" pitchFamily="34" charset="-120"/>
               </a:rPr>
-              <a:t>懒惰重建门各不相同</a:t>
-            </a:r>
-            <a:endParaRPr lang="en-US" sz="1400" dirty="0"/>
+              <a:t>业务侧照常走 HybridCLR 热更流程加载 DLL</a:t>
+            </a:r>
+            <a:endParaRPr lang="en-US" sz="1250" dirty="0"/>
           </a:p>
           <a:p>
             <a:pPr indent="0" marL="0">
@@ -9983,90 +10172,75 @@
                 <a:ea typeface="Microsoft YaHei" pitchFamily="34" charset="-122"/>
                 <a:cs typeface="Microsoft YaHei" pitchFamily="34" charset="-120"/>
               </a:rPr>
-              <a:t>methods / properties / events 按指针门；fields 按 size_inited 标志门 —— 置 NULL 必须连标志清</a:t>
-            </a:r>
-            <a:endParaRPr lang="en-US" sz="1400" dirty="0"/>
-          </a:p>
-        </p:txBody>
-      </p:sp>
-      <p:sp>
-        <p:nvSpPr>
-          <p:cNvPr id="18" name="Shape 16"/>
-          <p:cNvSpPr/>
-          <p:nvPr/>
-        </p:nvSpPr>
-        <p:spPr>
-          <a:xfrm>
-            <a:off x="6309360" y="2999232"/>
-            <a:ext cx="5486400" cy="1463040"/>
-          </a:xfrm>
-          <a:prstGeom prst="rect">
-            <a:avLst/>
-          </a:prstGeom>
-          <a:solidFill>
-            <a:srgbClr val="FFFFFF"/>
-          </a:solidFill>
-          <a:ln w="12700">
-            <a:solidFill>
-              <a:srgbClr val="DCE3EC"/>
-            </a:solidFill>
-            <a:prstDash val="solid"/>
-          </a:ln>
-          <a:effectLst>
-            <a:outerShdw sx="100000" sy="100000" kx="0" ky="0" algn="bl" rotWithShape="0" blurRad="101600" dist="25400" dir="5400000">
-              <a:srgbClr val="16233B">
-                <a:alpha val="10000"/>
-              </a:srgbClr>
-            </a:outerShdw>
-          </a:effectLst>
-        </p:spPr>
-      </p:sp>
-      <p:sp>
-        <p:nvSpPr>
-          <p:cNvPr id="19" name="Shape 17"/>
-          <p:cNvSpPr/>
-          <p:nvPr/>
-        </p:nvSpPr>
-        <p:spPr>
-          <a:xfrm>
-            <a:off x="6473952" y="3163824"/>
-            <a:ext cx="475488" cy="475488"/>
-          </a:xfrm>
-          <a:prstGeom prst="ellipse">
-            <a:avLst/>
-          </a:prstGeom>
-          <a:solidFill>
-            <a:srgbClr val="20344F"/>
-          </a:solidFill>
-          <a:ln/>
-        </p:spPr>
-      </p:sp>
-      <p:sp>
-        <p:nvSpPr>
-          <p:cNvPr id="20" name="Text 18"/>
-          <p:cNvSpPr/>
-          <p:nvPr/>
-        </p:nvSpPr>
-        <p:spPr>
-          <a:xfrm>
-            <a:off x="6473952" y="3163824"/>
-            <a:ext cx="475488" cy="475488"/>
-          </a:xfrm>
-          <a:prstGeom prst="rect">
-            <a:avLst/>
-          </a:prstGeom>
-          <a:noFill/>
-          <a:ln/>
-        </p:spPr>
-        <p:txBody>
-          <a:bodyPr wrap="square" lIns="0" tIns="0" rIns="0" bIns="0" rtlCol="0" anchor="ctr"/>
-          <a:lstStyle/>
-          <a:p>
-            <a:pPr algn="ctr" indent="0" marL="0">
-              <a:buNone/>
-            </a:pPr>
-            <a:r>
-              <a:rPr lang="en-US" sz="1600" b="1" dirty="0">
+              <a:t>同一程序集二次加载即触发热重载路径：复用旧类 / 旧方法指针，原地接上新元数据</a:t>
+            </a:r>
+            <a:endParaRPr lang="en-US" sz="1250" dirty="0"/>
+          </a:p>
+        </p:txBody>
+      </p:sp>
+      <p:sp>
+        <p:nvSpPr>
+          <p:cNvPr id="20" name="Shape 18"/>
+          <p:cNvSpPr/>
+          <p:nvPr/>
+        </p:nvSpPr>
+        <p:spPr>
+          <a:xfrm>
+            <a:off x="502920" y="5074920"/>
+            <a:ext cx="11292840" cy="1188720"/>
+          </a:xfrm>
+          <a:prstGeom prst="rect">
+            <a:avLst/>
+          </a:prstGeom>
+          <a:solidFill>
+            <a:srgbClr val="16233B"/>
+          </a:solidFill>
+          <a:ln/>
+        </p:spPr>
+      </p:sp>
+      <p:sp>
+        <p:nvSpPr>
+          <p:cNvPr id="21" name="Text 19"/>
+          <p:cNvSpPr/>
+          <p:nvPr/>
+        </p:nvSpPr>
+        <p:spPr>
+          <a:xfrm>
+            <a:off x="777240" y="5230368"/>
+            <a:ext cx="10789920" cy="914400"/>
+          </a:xfrm>
+          <a:prstGeom prst="rect">
+            <a:avLst/>
+          </a:prstGeom>
+          <a:noFill/>
+          <a:ln/>
+        </p:spPr>
+        <p:txBody>
+          <a:bodyPr wrap="square" lIns="0" tIns="0" rIns="0" bIns="0" rtlCol="0" anchor="t"/>
+          <a:lstStyle/>
+          <a:p>
+            <a:pPr indent="0" marL="0">
+              <a:buNone/>
+            </a:pPr>
+            <a:r>
+              <a:rPr lang="en-US" sz="1350" b="1" dirty="0">
+                <a:solidFill>
+                  <a:srgbClr val="0E9AA8"/>
+                </a:solidFill>
+                <a:latin typeface="Microsoft YaHei" pitchFamily="34" charset="0"/>
+                <a:ea typeface="Microsoft YaHei" pitchFamily="34" charset="-122"/>
+                <a:cs typeface="Microsoft YaHei" pitchFamily="34" charset="-120"/>
+              </a:rPr>
+              <a:t>为什么这么简单？</a:t>
+            </a:r>
+            <a:endParaRPr lang="en-US" sz="1350" dirty="0"/>
+          </a:p>
+          <a:p>
+            <a:pPr indent="0" marL="0">
+              <a:buNone/>
+            </a:pPr>
+            <a:r>
+              <a:rPr lang="en-US" sz="1200" dirty="0">
                 <a:solidFill>
                   <a:srgbClr val="FFFFFF"/>
                 </a:solidFill>
@@ -10074,359 +10248,9 @@
                 <a:ea typeface="Microsoft YaHei" pitchFamily="34" charset="-122"/>
                 <a:cs typeface="Microsoft YaHei" pitchFamily="34" charset="-120"/>
               </a:rPr>
-              <a:t>4</a:t>
-            </a:r>
-            <a:endParaRPr lang="en-US" sz="1600" dirty="0"/>
-          </a:p>
-        </p:txBody>
-      </p:sp>
-      <p:sp>
-        <p:nvSpPr>
-          <p:cNvPr id="21" name="Text 19"/>
-          <p:cNvSpPr/>
-          <p:nvPr/>
-        </p:nvSpPr>
-        <p:spPr>
-          <a:xfrm>
-            <a:off x="7114032" y="3127248"/>
-            <a:ext cx="4572000" cy="1234440"/>
-          </a:xfrm>
-          <a:prstGeom prst="rect">
-            <a:avLst/>
-          </a:prstGeom>
-          <a:noFill/>
-          <a:ln/>
-        </p:spPr>
-        <p:txBody>
-          <a:bodyPr wrap="square" lIns="0" tIns="0" rIns="0" bIns="0" rtlCol="0" anchor="t"/>
-          <a:lstStyle/>
-          <a:p>
-            <a:pPr indent="0" marL="0">
-              <a:buNone/>
-            </a:pPr>
-            <a:r>
-              <a:rPr lang="en-US" sz="1400" b="1" dirty="0">
-                <a:solidFill>
-                  <a:srgbClr val="16233B"/>
-                </a:solidFill>
-                <a:latin typeface="Microsoft YaHei" pitchFamily="34" charset="0"/>
-                <a:ea typeface="Microsoft YaHei" pitchFamily="34" charset="-122"/>
-                <a:cs typeface="Microsoft YaHei" pitchFamily="34" charset="-120"/>
-              </a:rPr>
-              <a:t>修复代码三重安全</a:t>
-            </a:r>
-            <a:endParaRPr lang="en-US" sz="1400" dirty="0"/>
-          </a:p>
-          <a:p>
-            <a:pPr indent="0" marL="0">
-              <a:buNone/>
-            </a:pPr>
-            <a:r>
-              <a:rPr lang="en-US" sz="1100" dirty="0">
-                <a:solidFill>
-                  <a:srgbClr val="63748A"/>
-                </a:solidFill>
-                <a:latin typeface="Microsoft YaHei" pitchFamily="34" charset="0"/>
-                <a:ea typeface="Microsoft YaHei" pitchFamily="34" charset="-122"/>
-                <a:cs typeface="Microsoft YaHei" pitchFamily="34" charset="-120"/>
-              </a:rPr>
-              <a:t>重载后启用的代码必须：启动期安全 + 递归安全 + restore Pass 期间静默（守卫计数器）</a:t>
-            </a:r>
-            <a:endParaRPr lang="en-US" sz="1400" dirty="0"/>
-          </a:p>
-        </p:txBody>
-      </p:sp>
-      <p:sp>
-        <p:nvSpPr>
-          <p:cNvPr id="22" name="Shape 20"/>
-          <p:cNvSpPr/>
-          <p:nvPr/>
-        </p:nvSpPr>
-        <p:spPr>
-          <a:xfrm>
-            <a:off x="502920" y="4626864"/>
-            <a:ext cx="5486400" cy="1463040"/>
-          </a:xfrm>
-          <a:prstGeom prst="rect">
-            <a:avLst/>
-          </a:prstGeom>
-          <a:solidFill>
-            <a:srgbClr val="FFFFFF"/>
-          </a:solidFill>
-          <a:ln w="12700">
-            <a:solidFill>
-              <a:srgbClr val="DCE3EC"/>
-            </a:solidFill>
-            <a:prstDash val="solid"/>
-          </a:ln>
-          <a:effectLst>
-            <a:outerShdw sx="100000" sy="100000" kx="0" ky="0" algn="bl" rotWithShape="0" blurRad="101600" dist="25400" dir="5400000">
-              <a:srgbClr val="16233B">
-                <a:alpha val="10000"/>
-              </a:srgbClr>
-            </a:outerShdw>
-          </a:effectLst>
-        </p:spPr>
-      </p:sp>
-      <p:sp>
-        <p:nvSpPr>
-          <p:cNvPr id="23" name="Shape 21"/>
-          <p:cNvSpPr/>
-          <p:nvPr/>
-        </p:nvSpPr>
-        <p:spPr>
-          <a:xfrm>
-            <a:off x="667512" y="4791456"/>
-            <a:ext cx="475488" cy="475488"/>
-          </a:xfrm>
-          <a:prstGeom prst="ellipse">
-            <a:avLst/>
-          </a:prstGeom>
-          <a:solidFill>
-            <a:srgbClr val="20344F"/>
-          </a:solidFill>
-          <a:ln/>
-        </p:spPr>
-      </p:sp>
-      <p:sp>
-        <p:nvSpPr>
-          <p:cNvPr id="24" name="Text 22"/>
-          <p:cNvSpPr/>
-          <p:nvPr/>
-        </p:nvSpPr>
-        <p:spPr>
-          <a:xfrm>
-            <a:off x="667512" y="4791456"/>
-            <a:ext cx="475488" cy="475488"/>
-          </a:xfrm>
-          <a:prstGeom prst="rect">
-            <a:avLst/>
-          </a:prstGeom>
-          <a:noFill/>
-          <a:ln/>
-        </p:spPr>
-        <p:txBody>
-          <a:bodyPr wrap="square" lIns="0" tIns="0" rIns="0" bIns="0" rtlCol="0" anchor="ctr"/>
-          <a:lstStyle/>
-          <a:p>
-            <a:pPr algn="ctr" indent="0" marL="0">
-              <a:buNone/>
-            </a:pPr>
-            <a:r>
-              <a:rPr lang="en-US" sz="1600" b="1" dirty="0">
-                <a:solidFill>
-                  <a:srgbClr val="FFFFFF"/>
-                </a:solidFill>
-                <a:latin typeface="Microsoft YaHei" pitchFamily="34" charset="0"/>
-                <a:ea typeface="Microsoft YaHei" pitchFamily="34" charset="-122"/>
-                <a:cs typeface="Microsoft YaHei" pitchFamily="34" charset="-120"/>
-              </a:rPr>
-              <a:t>5</a:t>
-            </a:r>
-            <a:endParaRPr lang="en-US" sz="1600" dirty="0"/>
-          </a:p>
-        </p:txBody>
-      </p:sp>
-      <p:sp>
-        <p:nvSpPr>
-          <p:cNvPr id="25" name="Text 23"/>
-          <p:cNvSpPr/>
-          <p:nvPr/>
-        </p:nvSpPr>
-        <p:spPr>
-          <a:xfrm>
-            <a:off x="1307592" y="4754880"/>
-            <a:ext cx="4572000" cy="1234440"/>
-          </a:xfrm>
-          <a:prstGeom prst="rect">
-            <a:avLst/>
-          </a:prstGeom>
-          <a:noFill/>
-          <a:ln/>
-        </p:spPr>
-        <p:txBody>
-          <a:bodyPr wrap="square" lIns="0" tIns="0" rIns="0" bIns="0" rtlCol="0" anchor="t"/>
-          <a:lstStyle/>
-          <a:p>
-            <a:pPr indent="0" marL="0">
-              <a:buNone/>
-            </a:pPr>
-            <a:r>
-              <a:rPr lang="en-US" sz="1400" b="1" dirty="0">
-                <a:solidFill>
-                  <a:srgbClr val="16233B"/>
-                </a:solidFill>
-                <a:latin typeface="Microsoft YaHei" pitchFamily="34" charset="0"/>
-                <a:ea typeface="Microsoft YaHei" pitchFamily="34" charset="-122"/>
-                <a:cs typeface="Microsoft YaHei" pitchFamily="34" charset="-120"/>
-              </a:rPr>
-              <a:t>诊断先行</a:t>
-            </a:r>
-            <a:endParaRPr lang="en-US" sz="1400" dirty="0"/>
-          </a:p>
-          <a:p>
-            <a:pPr indent="0" marL="0">
-              <a:buNone/>
-            </a:pPr>
-            <a:r>
-              <a:rPr lang="en-US" sz="1100" dirty="0">
-                <a:solidFill>
-                  <a:srgbClr val="63748A"/>
-                </a:solidFill>
-                <a:latin typeface="Microsoft YaHei" pitchFamily="34" charset="0"/>
-                <a:ea typeface="Microsoft YaHei" pitchFamily="34" charset="-122"/>
-                <a:cs typeface="Microsoft YaHei" pitchFamily="34" charset="-120"/>
-              </a:rPr>
-              <a:t>双写日志 + 重入保护 + 逐 opcode 验证；让 bug 自己说话，比读代码猜根因快一个数量级</a:t>
-            </a:r>
-            <a:endParaRPr lang="en-US" sz="1400" dirty="0"/>
-          </a:p>
-        </p:txBody>
-      </p:sp>
-      <p:sp>
-        <p:nvSpPr>
-          <p:cNvPr id="26" name="Shape 24"/>
-          <p:cNvSpPr/>
-          <p:nvPr/>
-        </p:nvSpPr>
-        <p:spPr>
-          <a:xfrm>
-            <a:off x="6309360" y="4626864"/>
-            <a:ext cx="5486400" cy="1463040"/>
-          </a:xfrm>
-          <a:prstGeom prst="rect">
-            <a:avLst/>
-          </a:prstGeom>
-          <a:solidFill>
-            <a:srgbClr val="FFFFFF"/>
-          </a:solidFill>
-          <a:ln w="12700">
-            <a:solidFill>
-              <a:srgbClr val="DCE3EC"/>
-            </a:solidFill>
-            <a:prstDash val="solid"/>
-          </a:ln>
-          <a:effectLst>
-            <a:outerShdw sx="100000" sy="100000" kx="0" ky="0" algn="bl" rotWithShape="0" blurRad="101600" dist="25400" dir="5400000">
-              <a:srgbClr val="16233B">
-                <a:alpha val="10000"/>
-              </a:srgbClr>
-            </a:outerShdw>
-          </a:effectLst>
-        </p:spPr>
-      </p:sp>
-      <p:sp>
-        <p:nvSpPr>
-          <p:cNvPr id="27" name="Shape 25"/>
-          <p:cNvSpPr/>
-          <p:nvPr/>
-        </p:nvSpPr>
-        <p:spPr>
-          <a:xfrm>
-            <a:off x="6473952" y="4791456"/>
-            <a:ext cx="475488" cy="475488"/>
-          </a:xfrm>
-          <a:prstGeom prst="ellipse">
-            <a:avLst/>
-          </a:prstGeom>
-          <a:solidFill>
-            <a:srgbClr val="20344F"/>
-          </a:solidFill>
-          <a:ln/>
-        </p:spPr>
-      </p:sp>
-      <p:sp>
-        <p:nvSpPr>
-          <p:cNvPr id="28" name="Text 26"/>
-          <p:cNvSpPr/>
-          <p:nvPr/>
-        </p:nvSpPr>
-        <p:spPr>
-          <a:xfrm>
-            <a:off x="6473952" y="4791456"/>
-            <a:ext cx="475488" cy="475488"/>
-          </a:xfrm>
-          <a:prstGeom prst="rect">
-            <a:avLst/>
-          </a:prstGeom>
-          <a:noFill/>
-          <a:ln/>
-        </p:spPr>
-        <p:txBody>
-          <a:bodyPr wrap="square" lIns="0" tIns="0" rIns="0" bIns="0" rtlCol="0" anchor="ctr"/>
-          <a:lstStyle/>
-          <a:p>
-            <a:pPr algn="ctr" indent="0" marL="0">
-              <a:buNone/>
-            </a:pPr>
-            <a:r>
-              <a:rPr lang="en-US" sz="1600" b="1" dirty="0">
-                <a:solidFill>
-                  <a:srgbClr val="FFFFFF"/>
-                </a:solidFill>
-                <a:latin typeface="Microsoft YaHei" pitchFamily="34" charset="0"/>
-                <a:ea typeface="Microsoft YaHei" pitchFamily="34" charset="-122"/>
-                <a:cs typeface="Microsoft YaHei" pitchFamily="34" charset="-120"/>
-              </a:rPr>
-              <a:t>6</a:t>
-            </a:r>
-            <a:endParaRPr lang="en-US" sz="1600" dirty="0"/>
-          </a:p>
-        </p:txBody>
-      </p:sp>
-      <p:sp>
-        <p:nvSpPr>
-          <p:cNvPr id="29" name="Text 27"/>
-          <p:cNvSpPr/>
-          <p:nvPr/>
-        </p:nvSpPr>
-        <p:spPr>
-          <a:xfrm>
-            <a:off x="7114032" y="4754880"/>
-            <a:ext cx="4572000" cy="1234440"/>
-          </a:xfrm>
-          <a:prstGeom prst="rect">
-            <a:avLst/>
-          </a:prstGeom>
-          <a:noFill/>
-          <a:ln/>
-        </p:spPr>
-        <p:txBody>
-          <a:bodyPr wrap="square" lIns="0" tIns="0" rIns="0" bIns="0" rtlCol="0" anchor="t"/>
-          <a:lstStyle/>
-          <a:p>
-            <a:pPr indent="0" marL="0">
-              <a:buNone/>
-            </a:pPr>
-            <a:r>
-              <a:rPr lang="en-US" sz="1400" b="1" dirty="0">
-                <a:solidFill>
-                  <a:srgbClr val="16233B"/>
-                </a:solidFill>
-                <a:latin typeface="Microsoft YaHei" pitchFamily="34" charset="0"/>
-                <a:ea typeface="Microsoft YaHei" pitchFamily="34" charset="-122"/>
-                <a:cs typeface="Microsoft YaHei" pitchFamily="34" charset="-120"/>
-              </a:rPr>
-              <a:t>跨平台纪律</a:t>
-            </a:r>
-            <a:endParaRPr lang="en-US" sz="1400" dirty="0"/>
-          </a:p>
-          <a:p>
-            <a:pPr indent="0" marL="0">
-              <a:buNone/>
-            </a:pPr>
-            <a:r>
-              <a:rPr lang="en-US" sz="1100" dirty="0">
-                <a:solidFill>
-                  <a:srgbClr val="63748A"/>
-                </a:solidFill>
-                <a:latin typeface="Microsoft YaHei" pitchFamily="34" charset="0"/>
-                <a:ea typeface="Microsoft YaHei" pitchFamily="34" charset="-122"/>
-                <a:cs typeface="Microsoft YaHei" pitchFamily="34" charset="-120"/>
-              </a:rPr>
-              <a:t>标准 C++ 单一路径（std::gmtime 等），禁止仅 Windows 的功能分支，仅允许告警抑制 pragma</a:t>
-            </a:r>
-            <a:endParaRPr lang="en-US" sz="1400" dirty="0"/>
+              <a:t>全部改造都在 libil2cpp 层完成 —— 对 Unity 引擎与 HybridCLR 上层完全透明，不依赖任何 Unity 版本特定补丁；升级 Unity 时只需对新版 LocalIl2CppData 重新做一次替换。</a:t>
+            </a:r>
+            <a:endParaRPr lang="en-US" sz="1350" dirty="0"/>
           </a:p>
         </p:txBody>
       </p:sp>
@@ -10444,7 +10268,7 @@
     <p:bg>
       <p:bgPr>
         <a:solidFill>
-          <a:srgbClr val="16233B"/>
+          <a:srgbClr val="F4F6F9"/>
         </a:solidFill>
       </p:bgPr>
     </p:bg>
@@ -10471,7 +10295,7 @@
         <p:spPr>
           <a:xfrm>
             <a:off x="0" y="0"/>
-            <a:ext cx="12191695" cy="6858000"/>
+            <a:ext cx="164592" cy="6858000"/>
           </a:xfrm>
           <a:prstGeom prst="rect">
             <a:avLst/>
@@ -10484,16 +10308,165 @@
       </p:sp>
       <p:sp>
         <p:nvSpPr>
-          <p:cNvPr id="3" name="Shape 1"/>
-          <p:cNvSpPr/>
-          <p:nvPr/>
-        </p:nvSpPr>
-        <p:spPr>
-          <a:xfrm>
-            <a:off x="822960" y="2377440"/>
-            <a:ext cx="128016" cy="1554480"/>
-          </a:xfrm>
-          <a:prstGeom prst="rect">
+          <p:cNvPr id="3" name="Text 1"/>
+          <p:cNvSpPr/>
+          <p:nvPr/>
+        </p:nvSpPr>
+        <p:spPr>
+          <a:xfrm>
+            <a:off x="502920" y="292608"/>
+            <a:ext cx="10515600" cy="292608"/>
+          </a:xfrm>
+          <a:prstGeom prst="rect">
+            <a:avLst/>
+          </a:prstGeom>
+          <a:noFill/>
+          <a:ln/>
+        </p:spPr>
+        <p:txBody>
+          <a:bodyPr wrap="square" lIns="0" tIns="0" rIns="0" bIns="0" rtlCol="0" anchor="ctr"/>
+          <a:lstStyle/>
+          <a:p>
+            <a:pPr indent="0" marL="0">
+              <a:buNone/>
+            </a:pPr>
+            <a:r>
+              <a:rPr lang="en-US" sz="1200" b="1" spc="200" kern="0" dirty="0">
+                <a:solidFill>
+                  <a:srgbClr val="0B7E89"/>
+                </a:solidFill>
+                <a:latin typeface="Microsoft YaHei" pitchFamily="34" charset="0"/>
+                <a:ea typeface="Microsoft YaHei" pitchFamily="34" charset="-122"/>
+                <a:cs typeface="Microsoft YaHei" pitchFamily="34" charset="-120"/>
+              </a:rPr>
+              <a:t>Takeaways</a:t>
+            </a:r>
+            <a:endParaRPr lang="en-US" sz="1200" dirty="0"/>
+          </a:p>
+        </p:txBody>
+      </p:sp>
+      <p:sp>
+        <p:nvSpPr>
+          <p:cNvPr id="4" name="Text 2"/>
+          <p:cNvSpPr/>
+          <p:nvPr/>
+        </p:nvSpPr>
+        <p:spPr>
+          <a:xfrm>
+            <a:off x="502920" y="566928"/>
+            <a:ext cx="11155680" cy="566928"/>
+          </a:xfrm>
+          <a:prstGeom prst="rect">
+            <a:avLst/>
+          </a:prstGeom>
+          <a:noFill/>
+          <a:ln/>
+        </p:spPr>
+        <p:txBody>
+          <a:bodyPr wrap="square" lIns="0" tIns="0" rIns="0" bIns="0" rtlCol="0" anchor="ctr"/>
+          <a:lstStyle/>
+          <a:p>
+            <a:pPr indent="0" marL="0">
+              <a:buNone/>
+            </a:pPr>
+            <a:r>
+              <a:rPr lang="en-US" sz="2800" b="1" dirty="0">
+                <a:solidFill>
+                  <a:srgbClr val="16233B"/>
+                </a:solidFill>
+                <a:latin typeface="Microsoft YaHei" pitchFamily="34" charset="0"/>
+                <a:ea typeface="Microsoft YaHei" pitchFamily="34" charset="-122"/>
+                <a:cs typeface="Microsoft YaHei" pitchFamily="34" charset="-120"/>
+              </a:rPr>
+              <a:t>经验总结</a:t>
+            </a:r>
+            <a:endParaRPr lang="en-US" sz="2800" dirty="0"/>
+          </a:p>
+        </p:txBody>
+      </p:sp>
+      <p:sp>
+        <p:nvSpPr>
+          <p:cNvPr id="5" name="Text 3"/>
+          <p:cNvSpPr/>
+          <p:nvPr/>
+        </p:nvSpPr>
+        <p:spPr>
+          <a:xfrm>
+            <a:off x="11475720" y="6419088"/>
+            <a:ext cx="548640" cy="320040"/>
+          </a:xfrm>
+          <a:prstGeom prst="rect">
+            <a:avLst/>
+          </a:prstGeom>
+          <a:noFill/>
+          <a:ln/>
+        </p:spPr>
+        <p:txBody>
+          <a:bodyPr wrap="square" lIns="0" tIns="0" rIns="0" bIns="0" rtlCol="0" anchor="ctr"/>
+          <a:lstStyle/>
+          <a:p>
+            <a:pPr algn="r" indent="0" marL="0">
+              <a:buNone/>
+            </a:pPr>
+            <a:r>
+              <a:rPr lang="en-US" sz="1100" dirty="0">
+                <a:solidFill>
+                  <a:srgbClr val="63748A"/>
+                </a:solidFill>
+                <a:latin typeface="Microsoft YaHei" pitchFamily="34" charset="0"/>
+                <a:ea typeface="Microsoft YaHei" pitchFamily="34" charset="-122"/>
+                <a:cs typeface="Microsoft YaHei" pitchFamily="34" charset="-120"/>
+              </a:rPr>
+              <a:t>18</a:t>
+            </a:r>
+            <a:endParaRPr lang="en-US" sz="1100" dirty="0"/>
+          </a:p>
+        </p:txBody>
+      </p:sp>
+      <p:sp>
+        <p:nvSpPr>
+          <p:cNvPr id="6" name="Shape 4"/>
+          <p:cNvSpPr/>
+          <p:nvPr/>
+        </p:nvSpPr>
+        <p:spPr>
+          <a:xfrm>
+            <a:off x="502920" y="1371600"/>
+            <a:ext cx="5486400" cy="1463040"/>
+          </a:xfrm>
+          <a:prstGeom prst="rect">
+            <a:avLst/>
+          </a:prstGeom>
+          <a:solidFill>
+            <a:srgbClr val="FFFFFF"/>
+          </a:solidFill>
+          <a:ln w="12700">
+            <a:solidFill>
+              <a:srgbClr val="DCE3EC"/>
+            </a:solidFill>
+            <a:prstDash val="solid"/>
+          </a:ln>
+          <a:effectLst>
+            <a:outerShdw sx="100000" sy="100000" kx="0" ky="0" algn="bl" rotWithShape="0" blurRad="101600" dist="25400" dir="5400000">
+              <a:srgbClr val="16233B">
+                <a:alpha val="10000"/>
+              </a:srgbClr>
+            </a:outerShdw>
+          </a:effectLst>
+        </p:spPr>
+      </p:sp>
+      <p:sp>
+        <p:nvSpPr>
+          <p:cNvPr id="7" name="Shape 5"/>
+          <p:cNvSpPr/>
+          <p:nvPr/>
+        </p:nvSpPr>
+        <p:spPr>
+          <a:xfrm>
+            <a:off x="667512" y="1536192"/>
+            <a:ext cx="475488" cy="475488"/>
+          </a:xfrm>
+          <a:prstGeom prst="ellipse">
             <a:avLst/>
           </a:prstGeom>
           <a:solidFill>
@@ -10504,14 +10477,14 @@
       </p:sp>
       <p:sp>
         <p:nvSpPr>
-          <p:cNvPr id="4" name="Text 2"/>
-          <p:cNvSpPr/>
-          <p:nvPr/>
-        </p:nvSpPr>
-        <p:spPr>
-          <a:xfrm>
-            <a:off x="1143000" y="2331720"/>
-            <a:ext cx="10058400" cy="731520"/>
+          <p:cNvPr id="8" name="Text 6"/>
+          <p:cNvSpPr/>
+          <p:nvPr/>
+        </p:nvSpPr>
+        <p:spPr>
+          <a:xfrm>
+            <a:off x="667512" y="1536192"/>
+            <a:ext cx="475488" cy="475488"/>
           </a:xfrm>
           <a:prstGeom prst="rect">
             <a:avLst/>
@@ -10523,11 +10496,11 @@
           <a:bodyPr wrap="square" lIns="0" tIns="0" rIns="0" bIns="0" rtlCol="0" anchor="ctr"/>
           <a:lstStyle/>
           <a:p>
-            <a:pPr indent="0" marL="0">
-              <a:buNone/>
-            </a:pPr>
-            <a:r>
-              <a:rPr lang="en-US" sz="2800" b="1" dirty="0">
+            <a:pPr algn="ctr" indent="0" marL="0">
+              <a:buNone/>
+            </a:pPr>
+            <a:r>
+              <a:rPr lang="en-US" sz="1600" b="1" dirty="0">
                 <a:solidFill>
                   <a:srgbClr val="FFFFFF"/>
                 </a:solidFill>
@@ -10535,22 +10508,130 @@
                 <a:ea typeface="Microsoft YaHei" pitchFamily="34" charset="-122"/>
                 <a:cs typeface="Microsoft YaHei" pitchFamily="34" charset="-120"/>
               </a:rPr>
-              <a:t>热重载的复杂度，是在为运行时内部一致性付账</a:t>
-            </a:r>
-            <a:endParaRPr lang="en-US" sz="2800" dirty="0"/>
-          </a:p>
-        </p:txBody>
-      </p:sp>
-      <p:sp>
-        <p:nvSpPr>
-          <p:cNvPr id="5" name="Text 3"/>
-          <p:cNvSpPr/>
-          <p:nvPr/>
-        </p:nvSpPr>
-        <p:spPr>
-          <a:xfrm>
-            <a:off x="1143000" y="3154680"/>
-            <a:ext cx="10058400" cy="457200"/>
+              <a:t>1</a:t>
+            </a:r>
+            <a:endParaRPr lang="en-US" sz="1600" dirty="0"/>
+          </a:p>
+        </p:txBody>
+      </p:sp>
+      <p:sp>
+        <p:nvSpPr>
+          <p:cNvPr id="9" name="Text 7"/>
+          <p:cNvSpPr/>
+          <p:nvPr/>
+        </p:nvSpPr>
+        <p:spPr>
+          <a:xfrm>
+            <a:off x="1307592" y="1499616"/>
+            <a:ext cx="4572000" cy="1234440"/>
+          </a:xfrm>
+          <a:prstGeom prst="rect">
+            <a:avLst/>
+          </a:prstGeom>
+          <a:noFill/>
+          <a:ln/>
+        </p:spPr>
+        <p:txBody>
+          <a:bodyPr wrap="square" lIns="0" tIns="0" rIns="0" bIns="0" rtlCol="0" anchor="t"/>
+          <a:lstStyle/>
+          <a:p>
+            <a:pPr indent="0" marL="0">
+              <a:buNone/>
+            </a:pPr>
+            <a:r>
+              <a:rPr lang="en-US" sz="1400" b="1" dirty="0">
+                <a:solidFill>
+                  <a:srgbClr val="16233B"/>
+                </a:solidFill>
+                <a:latin typeface="Microsoft YaHei" pitchFamily="34" charset="0"/>
+                <a:ea typeface="Microsoft YaHei" pitchFamily="34" charset="-122"/>
+                <a:cs typeface="Microsoft YaHei" pitchFamily="34" charset="-120"/>
+              </a:rPr>
+              <a:t>指针即身份</a:t>
+            </a:r>
+            <a:endParaRPr lang="en-US" sz="1400" dirty="0"/>
+          </a:p>
+          <a:p>
+            <a:pPr indent="0" marL="0">
+              <a:buNone/>
+            </a:pPr>
+            <a:r>
+              <a:rPr lang="en-US" sz="1100" dirty="0">
+                <a:solidFill>
+                  <a:srgbClr val="63748A"/>
+                </a:solidFill>
+                <a:latin typeface="Microsoft YaHei" pitchFamily="34" charset="0"/>
+                <a:ea typeface="Microsoft YaHei" pitchFamily="34" charset="-122"/>
+                <a:cs typeface="Microsoft YaHei" pitchFamily="34" charset="-120"/>
+              </a:rPr>
+              <a:t>Unity 层 / API 层 / 托管层三层一致约束，只有复用能同时满足；同型两指针必然身份分裂</a:t>
+            </a:r>
+            <a:endParaRPr lang="en-US" sz="1400" dirty="0"/>
+          </a:p>
+        </p:txBody>
+      </p:sp>
+      <p:sp>
+        <p:nvSpPr>
+          <p:cNvPr id="10" name="Shape 8"/>
+          <p:cNvSpPr/>
+          <p:nvPr/>
+        </p:nvSpPr>
+        <p:spPr>
+          <a:xfrm>
+            <a:off x="6309360" y="1371600"/>
+            <a:ext cx="5486400" cy="1463040"/>
+          </a:xfrm>
+          <a:prstGeom prst="rect">
+            <a:avLst/>
+          </a:prstGeom>
+          <a:solidFill>
+            <a:srgbClr val="FFFFFF"/>
+          </a:solidFill>
+          <a:ln w="12700">
+            <a:solidFill>
+              <a:srgbClr val="DCE3EC"/>
+            </a:solidFill>
+            <a:prstDash val="solid"/>
+          </a:ln>
+          <a:effectLst>
+            <a:outerShdw sx="100000" sy="100000" kx="0" ky="0" algn="bl" rotWithShape="0" blurRad="101600" dist="25400" dir="5400000">
+              <a:srgbClr val="16233B">
+                <a:alpha val="10000"/>
+              </a:srgbClr>
+            </a:outerShdw>
+          </a:effectLst>
+        </p:spPr>
+      </p:sp>
+      <p:sp>
+        <p:nvSpPr>
+          <p:cNvPr id="11" name="Shape 9"/>
+          <p:cNvSpPr/>
+          <p:nvPr/>
+        </p:nvSpPr>
+        <p:spPr>
+          <a:xfrm>
+            <a:off x="6473952" y="1536192"/>
+            <a:ext cx="475488" cy="475488"/>
+          </a:xfrm>
+          <a:prstGeom prst="ellipse">
+            <a:avLst/>
+          </a:prstGeom>
+          <a:solidFill>
+            <a:srgbClr val="0E9AA8"/>
+          </a:solidFill>
+          <a:ln/>
+        </p:spPr>
+      </p:sp>
+      <p:sp>
+        <p:nvSpPr>
+          <p:cNvPr id="12" name="Text 10"/>
+          <p:cNvSpPr/>
+          <p:nvPr/>
+        </p:nvSpPr>
+        <p:spPr>
+          <a:xfrm>
+            <a:off x="6473952" y="1536192"/>
+            <a:ext cx="475488" cy="475488"/>
           </a:xfrm>
           <a:prstGeom prst="rect">
             <a:avLst/>
@@ -10562,19 +10643,19 @@
           <a:bodyPr wrap="square" lIns="0" tIns="0" rIns="0" bIns="0" rtlCol="0" anchor="ctr"/>
           <a:lstStyle/>
           <a:p>
-            <a:pPr indent="0" marL="0">
-              <a:buNone/>
-            </a:pPr>
-            <a:r>
-              <a:rPr lang="en-US" sz="1600" dirty="0">
-                <a:solidFill>
-                  <a:srgbClr val="9FB3C8"/>
-                </a:solidFill>
-                <a:latin typeface="Microsoft YaHei" pitchFamily="34" charset="0"/>
-                <a:ea typeface="Microsoft YaHei" pitchFamily="34" charset="-122"/>
-                <a:cs typeface="Microsoft YaHei" pitchFamily="34" charset="-120"/>
-              </a:rPr>
-              <a:t>复用不是目的，让三层指针身份唯一才是。</a:t>
+            <a:pPr algn="ctr" indent="0" marL="0">
+              <a:buNone/>
+            </a:pPr>
+            <a:r>
+              <a:rPr lang="en-US" sz="1600" b="1" dirty="0">
+                <a:solidFill>
+                  <a:srgbClr val="FFFFFF"/>
+                </a:solidFill>
+                <a:latin typeface="Microsoft YaHei" pitchFamily="34" charset="0"/>
+                <a:ea typeface="Microsoft YaHei" pitchFamily="34" charset="-122"/>
+                <a:cs typeface="Microsoft YaHei" pitchFamily="34" charset="-120"/>
+              </a:rPr>
+              <a:t>2</a:t>
             </a:r>
             <a:endParaRPr lang="en-US" sz="1600" dirty="0"/>
           </a:p>
@@ -10582,14 +10663,122 @@
       </p:sp>
       <p:sp>
         <p:nvSpPr>
-          <p:cNvPr id="6" name="Text 4"/>
-          <p:cNvSpPr/>
-          <p:nvPr/>
-        </p:nvSpPr>
-        <p:spPr>
-          <a:xfrm>
-            <a:off x="1143000" y="4206240"/>
-            <a:ext cx="5486400" cy="548640"/>
+          <p:cNvPr id="13" name="Text 11"/>
+          <p:cNvSpPr/>
+          <p:nvPr/>
+        </p:nvSpPr>
+        <p:spPr>
+          <a:xfrm>
+            <a:off x="7114032" y="1499616"/>
+            <a:ext cx="4572000" cy="1234440"/>
+          </a:xfrm>
+          <a:prstGeom prst="rect">
+            <a:avLst/>
+          </a:prstGeom>
+          <a:noFill/>
+          <a:ln/>
+        </p:spPr>
+        <p:txBody>
+          <a:bodyPr wrap="square" lIns="0" tIns="0" rIns="0" bIns="0" rtlCol="0" anchor="t"/>
+          <a:lstStyle/>
+          <a:p>
+            <a:pPr indent="0" marL="0">
+              <a:buNone/>
+            </a:pPr>
+            <a:r>
+              <a:rPr lang="en-US" sz="1400" b="1" dirty="0">
+                <a:solidFill>
+                  <a:srgbClr val="16233B"/>
+                </a:solidFill>
+                <a:latin typeface="Microsoft YaHei" pitchFamily="34" charset="0"/>
+                <a:ea typeface="Microsoft YaHei" pitchFamily="34" charset="-122"/>
+                <a:cs typeface="Microsoft YaHei" pitchFamily="34" charset="-120"/>
+              </a:rPr>
+              <a:t>缓存即雷区</a:t>
+            </a:r>
+            <a:endParaRPr lang="en-US" sz="1400" dirty="0"/>
+          </a:p>
+          <a:p>
+            <a:pPr indent="0" marL="0">
+              <a:buNone/>
+            </a:pPr>
+            <a:r>
+              <a:rPr lang="en-US" sz="1100" dirty="0">
+                <a:solidFill>
+                  <a:srgbClr val="63748A"/>
+                </a:solidFill>
+                <a:latin typeface="Microsoft YaHei" pitchFamily="34" charset="0"/>
+                <a:ea typeface="Microsoft YaHei" pitchFamily="34" charset="-122"/>
+                <a:cs typeface="Microsoft YaHei" pitchFamily="34" charset="-120"/>
+              </a:rPr>
+              <a:t>凡按裸指针 hash / 键控的缓存（泛型实例、TypeMap、MethodMap），重载后必须 rehash 或失效</a:t>
+            </a:r>
+            <a:endParaRPr lang="en-US" sz="1400" dirty="0"/>
+          </a:p>
+        </p:txBody>
+      </p:sp>
+      <p:sp>
+        <p:nvSpPr>
+          <p:cNvPr id="14" name="Shape 12"/>
+          <p:cNvSpPr/>
+          <p:nvPr/>
+        </p:nvSpPr>
+        <p:spPr>
+          <a:xfrm>
+            <a:off x="502920" y="2999232"/>
+            <a:ext cx="5486400" cy="1463040"/>
+          </a:xfrm>
+          <a:prstGeom prst="rect">
+            <a:avLst/>
+          </a:prstGeom>
+          <a:solidFill>
+            <a:srgbClr val="FFFFFF"/>
+          </a:solidFill>
+          <a:ln w="12700">
+            <a:solidFill>
+              <a:srgbClr val="DCE3EC"/>
+            </a:solidFill>
+            <a:prstDash val="solid"/>
+          </a:ln>
+          <a:effectLst>
+            <a:outerShdw sx="100000" sy="100000" kx="0" ky="0" algn="bl" rotWithShape="0" blurRad="101600" dist="25400" dir="5400000">
+              <a:srgbClr val="16233B">
+                <a:alpha val="10000"/>
+              </a:srgbClr>
+            </a:outerShdw>
+          </a:effectLst>
+        </p:spPr>
+      </p:sp>
+      <p:sp>
+        <p:nvSpPr>
+          <p:cNvPr id="15" name="Shape 13"/>
+          <p:cNvSpPr/>
+          <p:nvPr/>
+        </p:nvSpPr>
+        <p:spPr>
+          <a:xfrm>
+            <a:off x="667512" y="3163824"/>
+            <a:ext cx="475488" cy="475488"/>
+          </a:xfrm>
+          <a:prstGeom prst="ellipse">
+            <a:avLst/>
+          </a:prstGeom>
+          <a:solidFill>
+            <a:srgbClr val="0E9AA8"/>
+          </a:solidFill>
+          <a:ln/>
+        </p:spPr>
+      </p:sp>
+      <p:sp>
+        <p:nvSpPr>
+          <p:cNvPr id="16" name="Text 14"/>
+          <p:cNvSpPr/>
+          <p:nvPr/>
+        </p:nvSpPr>
+        <p:spPr>
+          <a:xfrm>
+            <a:off x="667512" y="3163824"/>
+            <a:ext cx="475488" cy="475488"/>
           </a:xfrm>
           <a:prstGeom prst="rect">
             <a:avLst/>
@@ -10601,21 +10790,518 @@
           <a:bodyPr wrap="square" lIns="0" tIns="0" rIns="0" bIns="0" rtlCol="0" anchor="ctr"/>
           <a:lstStyle/>
           <a:p>
-            <a:pPr indent="0" marL="0">
-              <a:buNone/>
-            </a:pPr>
-            <a:r>
-              <a:rPr lang="en-US" sz="2000" b="1" dirty="0">
-                <a:solidFill>
-                  <a:srgbClr val="0E9AA8"/>
-                </a:solidFill>
-                <a:latin typeface="Microsoft YaHei" pitchFamily="34" charset="0"/>
-                <a:ea typeface="Microsoft YaHei" pitchFamily="34" charset="-122"/>
-                <a:cs typeface="Microsoft YaHei" pitchFamily="34" charset="-120"/>
-              </a:rPr>
-              <a:t>Q &amp; A</a:t>
-            </a:r>
-            <a:endParaRPr lang="en-US" sz="2000" dirty="0"/>
+            <a:pPr algn="ctr" indent="0" marL="0">
+              <a:buNone/>
+            </a:pPr>
+            <a:r>
+              <a:rPr lang="en-US" sz="1600" b="1" dirty="0">
+                <a:solidFill>
+                  <a:srgbClr val="FFFFFF"/>
+                </a:solidFill>
+                <a:latin typeface="Microsoft YaHei" pitchFamily="34" charset="0"/>
+                <a:ea typeface="Microsoft YaHei" pitchFamily="34" charset="-122"/>
+                <a:cs typeface="Microsoft YaHei" pitchFamily="34" charset="-120"/>
+              </a:rPr>
+              <a:t>3</a:t>
+            </a:r>
+            <a:endParaRPr lang="en-US" sz="1600" dirty="0"/>
+          </a:p>
+        </p:txBody>
+      </p:sp>
+      <p:sp>
+        <p:nvSpPr>
+          <p:cNvPr id="17" name="Text 15"/>
+          <p:cNvSpPr/>
+          <p:nvPr/>
+        </p:nvSpPr>
+        <p:spPr>
+          <a:xfrm>
+            <a:off x="1307592" y="3127248"/>
+            <a:ext cx="4572000" cy="1234440"/>
+          </a:xfrm>
+          <a:prstGeom prst="rect">
+            <a:avLst/>
+          </a:prstGeom>
+          <a:noFill/>
+          <a:ln/>
+        </p:spPr>
+        <p:txBody>
+          <a:bodyPr wrap="square" lIns="0" tIns="0" rIns="0" bIns="0" rtlCol="0" anchor="t"/>
+          <a:lstStyle/>
+          <a:p>
+            <a:pPr indent="0" marL="0">
+              <a:buNone/>
+            </a:pPr>
+            <a:r>
+              <a:rPr lang="en-US" sz="1400" b="1" dirty="0">
+                <a:solidFill>
+                  <a:srgbClr val="16233B"/>
+                </a:solidFill>
+                <a:latin typeface="Microsoft YaHei" pitchFamily="34" charset="0"/>
+                <a:ea typeface="Microsoft YaHei" pitchFamily="34" charset="-122"/>
+                <a:cs typeface="Microsoft YaHei" pitchFamily="34" charset="-120"/>
+              </a:rPr>
+              <a:t>懒惰重建门各不相同</a:t>
+            </a:r>
+            <a:endParaRPr lang="en-US" sz="1400" dirty="0"/>
+          </a:p>
+          <a:p>
+            <a:pPr indent="0" marL="0">
+              <a:buNone/>
+            </a:pPr>
+            <a:r>
+              <a:rPr lang="en-US" sz="1100" dirty="0">
+                <a:solidFill>
+                  <a:srgbClr val="63748A"/>
+                </a:solidFill>
+                <a:latin typeface="Microsoft YaHei" pitchFamily="34" charset="0"/>
+                <a:ea typeface="Microsoft YaHei" pitchFamily="34" charset="-122"/>
+                <a:cs typeface="Microsoft YaHei" pitchFamily="34" charset="-120"/>
+              </a:rPr>
+              <a:t>methods / properties / events 按指针门；fields 按 size_inited 标志门 —— 置 NULL 必须连标志清</a:t>
+            </a:r>
+            <a:endParaRPr lang="en-US" sz="1400" dirty="0"/>
+          </a:p>
+        </p:txBody>
+      </p:sp>
+      <p:sp>
+        <p:nvSpPr>
+          <p:cNvPr id="18" name="Shape 16"/>
+          <p:cNvSpPr/>
+          <p:nvPr/>
+        </p:nvSpPr>
+        <p:spPr>
+          <a:xfrm>
+            <a:off x="6309360" y="2999232"/>
+            <a:ext cx="5486400" cy="1463040"/>
+          </a:xfrm>
+          <a:prstGeom prst="rect">
+            <a:avLst/>
+          </a:prstGeom>
+          <a:solidFill>
+            <a:srgbClr val="FFFFFF"/>
+          </a:solidFill>
+          <a:ln w="12700">
+            <a:solidFill>
+              <a:srgbClr val="DCE3EC"/>
+            </a:solidFill>
+            <a:prstDash val="solid"/>
+          </a:ln>
+          <a:effectLst>
+            <a:outerShdw sx="100000" sy="100000" kx="0" ky="0" algn="bl" rotWithShape="0" blurRad="101600" dist="25400" dir="5400000">
+              <a:srgbClr val="16233B">
+                <a:alpha val="10000"/>
+              </a:srgbClr>
+            </a:outerShdw>
+          </a:effectLst>
+        </p:spPr>
+      </p:sp>
+      <p:sp>
+        <p:nvSpPr>
+          <p:cNvPr id="19" name="Shape 17"/>
+          <p:cNvSpPr/>
+          <p:nvPr/>
+        </p:nvSpPr>
+        <p:spPr>
+          <a:xfrm>
+            <a:off x="6473952" y="3163824"/>
+            <a:ext cx="475488" cy="475488"/>
+          </a:xfrm>
+          <a:prstGeom prst="ellipse">
+            <a:avLst/>
+          </a:prstGeom>
+          <a:solidFill>
+            <a:srgbClr val="20344F"/>
+          </a:solidFill>
+          <a:ln/>
+        </p:spPr>
+      </p:sp>
+      <p:sp>
+        <p:nvSpPr>
+          <p:cNvPr id="20" name="Text 18"/>
+          <p:cNvSpPr/>
+          <p:nvPr/>
+        </p:nvSpPr>
+        <p:spPr>
+          <a:xfrm>
+            <a:off x="6473952" y="3163824"/>
+            <a:ext cx="475488" cy="475488"/>
+          </a:xfrm>
+          <a:prstGeom prst="rect">
+            <a:avLst/>
+          </a:prstGeom>
+          <a:noFill/>
+          <a:ln/>
+        </p:spPr>
+        <p:txBody>
+          <a:bodyPr wrap="square" lIns="0" tIns="0" rIns="0" bIns="0" rtlCol="0" anchor="ctr"/>
+          <a:lstStyle/>
+          <a:p>
+            <a:pPr algn="ctr" indent="0" marL="0">
+              <a:buNone/>
+            </a:pPr>
+            <a:r>
+              <a:rPr lang="en-US" sz="1600" b="1" dirty="0">
+                <a:solidFill>
+                  <a:srgbClr val="FFFFFF"/>
+                </a:solidFill>
+                <a:latin typeface="Microsoft YaHei" pitchFamily="34" charset="0"/>
+                <a:ea typeface="Microsoft YaHei" pitchFamily="34" charset="-122"/>
+                <a:cs typeface="Microsoft YaHei" pitchFamily="34" charset="-120"/>
+              </a:rPr>
+              <a:t>4</a:t>
+            </a:r>
+            <a:endParaRPr lang="en-US" sz="1600" dirty="0"/>
+          </a:p>
+        </p:txBody>
+      </p:sp>
+      <p:sp>
+        <p:nvSpPr>
+          <p:cNvPr id="21" name="Text 19"/>
+          <p:cNvSpPr/>
+          <p:nvPr/>
+        </p:nvSpPr>
+        <p:spPr>
+          <a:xfrm>
+            <a:off x="7114032" y="3127248"/>
+            <a:ext cx="4572000" cy="1234440"/>
+          </a:xfrm>
+          <a:prstGeom prst="rect">
+            <a:avLst/>
+          </a:prstGeom>
+          <a:noFill/>
+          <a:ln/>
+        </p:spPr>
+        <p:txBody>
+          <a:bodyPr wrap="square" lIns="0" tIns="0" rIns="0" bIns="0" rtlCol="0" anchor="t"/>
+          <a:lstStyle/>
+          <a:p>
+            <a:pPr indent="0" marL="0">
+              <a:buNone/>
+            </a:pPr>
+            <a:r>
+              <a:rPr lang="en-US" sz="1400" b="1" dirty="0">
+                <a:solidFill>
+                  <a:srgbClr val="16233B"/>
+                </a:solidFill>
+                <a:latin typeface="Microsoft YaHei" pitchFamily="34" charset="0"/>
+                <a:ea typeface="Microsoft YaHei" pitchFamily="34" charset="-122"/>
+                <a:cs typeface="Microsoft YaHei" pitchFamily="34" charset="-120"/>
+              </a:rPr>
+              <a:t>修复代码三重安全</a:t>
+            </a:r>
+            <a:endParaRPr lang="en-US" sz="1400" dirty="0"/>
+          </a:p>
+          <a:p>
+            <a:pPr indent="0" marL="0">
+              <a:buNone/>
+            </a:pPr>
+            <a:r>
+              <a:rPr lang="en-US" sz="1100" dirty="0">
+                <a:solidFill>
+                  <a:srgbClr val="63748A"/>
+                </a:solidFill>
+                <a:latin typeface="Microsoft YaHei" pitchFamily="34" charset="0"/>
+                <a:ea typeface="Microsoft YaHei" pitchFamily="34" charset="-122"/>
+                <a:cs typeface="Microsoft YaHei" pitchFamily="34" charset="-120"/>
+              </a:rPr>
+              <a:t>重载后启用的代码必须：启动期安全 + 递归安全 + restore Pass 期间静默（守卫计数器）</a:t>
+            </a:r>
+            <a:endParaRPr lang="en-US" sz="1400" dirty="0"/>
+          </a:p>
+        </p:txBody>
+      </p:sp>
+      <p:sp>
+        <p:nvSpPr>
+          <p:cNvPr id="22" name="Shape 20"/>
+          <p:cNvSpPr/>
+          <p:nvPr/>
+        </p:nvSpPr>
+        <p:spPr>
+          <a:xfrm>
+            <a:off x="502920" y="4626864"/>
+            <a:ext cx="5486400" cy="1463040"/>
+          </a:xfrm>
+          <a:prstGeom prst="rect">
+            <a:avLst/>
+          </a:prstGeom>
+          <a:solidFill>
+            <a:srgbClr val="FFFFFF"/>
+          </a:solidFill>
+          <a:ln w="12700">
+            <a:solidFill>
+              <a:srgbClr val="DCE3EC"/>
+            </a:solidFill>
+            <a:prstDash val="solid"/>
+          </a:ln>
+          <a:effectLst>
+            <a:outerShdw sx="100000" sy="100000" kx="0" ky="0" algn="bl" rotWithShape="0" blurRad="101600" dist="25400" dir="5400000">
+              <a:srgbClr val="16233B">
+                <a:alpha val="10000"/>
+              </a:srgbClr>
+            </a:outerShdw>
+          </a:effectLst>
+        </p:spPr>
+      </p:sp>
+      <p:sp>
+        <p:nvSpPr>
+          <p:cNvPr id="23" name="Shape 21"/>
+          <p:cNvSpPr/>
+          <p:nvPr/>
+        </p:nvSpPr>
+        <p:spPr>
+          <a:xfrm>
+            <a:off x="667512" y="4791456"/>
+            <a:ext cx="475488" cy="475488"/>
+          </a:xfrm>
+          <a:prstGeom prst="ellipse">
+            <a:avLst/>
+          </a:prstGeom>
+          <a:solidFill>
+            <a:srgbClr val="20344F"/>
+          </a:solidFill>
+          <a:ln/>
+        </p:spPr>
+      </p:sp>
+      <p:sp>
+        <p:nvSpPr>
+          <p:cNvPr id="24" name="Text 22"/>
+          <p:cNvSpPr/>
+          <p:nvPr/>
+        </p:nvSpPr>
+        <p:spPr>
+          <a:xfrm>
+            <a:off x="667512" y="4791456"/>
+            <a:ext cx="475488" cy="475488"/>
+          </a:xfrm>
+          <a:prstGeom prst="rect">
+            <a:avLst/>
+          </a:prstGeom>
+          <a:noFill/>
+          <a:ln/>
+        </p:spPr>
+        <p:txBody>
+          <a:bodyPr wrap="square" lIns="0" tIns="0" rIns="0" bIns="0" rtlCol="0" anchor="ctr"/>
+          <a:lstStyle/>
+          <a:p>
+            <a:pPr algn="ctr" indent="0" marL="0">
+              <a:buNone/>
+            </a:pPr>
+            <a:r>
+              <a:rPr lang="en-US" sz="1600" b="1" dirty="0">
+                <a:solidFill>
+                  <a:srgbClr val="FFFFFF"/>
+                </a:solidFill>
+                <a:latin typeface="Microsoft YaHei" pitchFamily="34" charset="0"/>
+                <a:ea typeface="Microsoft YaHei" pitchFamily="34" charset="-122"/>
+                <a:cs typeface="Microsoft YaHei" pitchFamily="34" charset="-120"/>
+              </a:rPr>
+              <a:t>5</a:t>
+            </a:r>
+            <a:endParaRPr lang="en-US" sz="1600" dirty="0"/>
+          </a:p>
+        </p:txBody>
+      </p:sp>
+      <p:sp>
+        <p:nvSpPr>
+          <p:cNvPr id="25" name="Text 23"/>
+          <p:cNvSpPr/>
+          <p:nvPr/>
+        </p:nvSpPr>
+        <p:spPr>
+          <a:xfrm>
+            <a:off x="1307592" y="4754880"/>
+            <a:ext cx="4572000" cy="1234440"/>
+          </a:xfrm>
+          <a:prstGeom prst="rect">
+            <a:avLst/>
+          </a:prstGeom>
+          <a:noFill/>
+          <a:ln/>
+        </p:spPr>
+        <p:txBody>
+          <a:bodyPr wrap="square" lIns="0" tIns="0" rIns="0" bIns="0" rtlCol="0" anchor="t"/>
+          <a:lstStyle/>
+          <a:p>
+            <a:pPr indent="0" marL="0">
+              <a:buNone/>
+            </a:pPr>
+            <a:r>
+              <a:rPr lang="en-US" sz="1400" b="1" dirty="0">
+                <a:solidFill>
+                  <a:srgbClr val="16233B"/>
+                </a:solidFill>
+                <a:latin typeface="Microsoft YaHei" pitchFamily="34" charset="0"/>
+                <a:ea typeface="Microsoft YaHei" pitchFamily="34" charset="-122"/>
+                <a:cs typeface="Microsoft YaHei" pitchFamily="34" charset="-120"/>
+              </a:rPr>
+              <a:t>诊断先行</a:t>
+            </a:r>
+            <a:endParaRPr lang="en-US" sz="1400" dirty="0"/>
+          </a:p>
+          <a:p>
+            <a:pPr indent="0" marL="0">
+              <a:buNone/>
+            </a:pPr>
+            <a:r>
+              <a:rPr lang="en-US" sz="1100" dirty="0">
+                <a:solidFill>
+                  <a:srgbClr val="63748A"/>
+                </a:solidFill>
+                <a:latin typeface="Microsoft YaHei" pitchFamily="34" charset="0"/>
+                <a:ea typeface="Microsoft YaHei" pitchFamily="34" charset="-122"/>
+                <a:cs typeface="Microsoft YaHei" pitchFamily="34" charset="-120"/>
+              </a:rPr>
+              <a:t>双写日志 + 重入保护 + 逐 opcode 验证；让 bug 自己说话，比读代码猜根因快一个数量级</a:t>
+            </a:r>
+            <a:endParaRPr lang="en-US" sz="1400" dirty="0"/>
+          </a:p>
+        </p:txBody>
+      </p:sp>
+      <p:sp>
+        <p:nvSpPr>
+          <p:cNvPr id="26" name="Shape 24"/>
+          <p:cNvSpPr/>
+          <p:nvPr/>
+        </p:nvSpPr>
+        <p:spPr>
+          <a:xfrm>
+            <a:off x="6309360" y="4626864"/>
+            <a:ext cx="5486400" cy="1463040"/>
+          </a:xfrm>
+          <a:prstGeom prst="rect">
+            <a:avLst/>
+          </a:prstGeom>
+          <a:solidFill>
+            <a:srgbClr val="FFFFFF"/>
+          </a:solidFill>
+          <a:ln w="12700">
+            <a:solidFill>
+              <a:srgbClr val="DCE3EC"/>
+            </a:solidFill>
+            <a:prstDash val="solid"/>
+          </a:ln>
+          <a:effectLst>
+            <a:outerShdw sx="100000" sy="100000" kx="0" ky="0" algn="bl" rotWithShape="0" blurRad="101600" dist="25400" dir="5400000">
+              <a:srgbClr val="16233B">
+                <a:alpha val="10000"/>
+              </a:srgbClr>
+            </a:outerShdw>
+          </a:effectLst>
+        </p:spPr>
+      </p:sp>
+      <p:sp>
+        <p:nvSpPr>
+          <p:cNvPr id="27" name="Shape 25"/>
+          <p:cNvSpPr/>
+          <p:nvPr/>
+        </p:nvSpPr>
+        <p:spPr>
+          <a:xfrm>
+            <a:off x="6473952" y="4791456"/>
+            <a:ext cx="475488" cy="475488"/>
+          </a:xfrm>
+          <a:prstGeom prst="ellipse">
+            <a:avLst/>
+          </a:prstGeom>
+          <a:solidFill>
+            <a:srgbClr val="20344F"/>
+          </a:solidFill>
+          <a:ln/>
+        </p:spPr>
+      </p:sp>
+      <p:sp>
+        <p:nvSpPr>
+          <p:cNvPr id="28" name="Text 26"/>
+          <p:cNvSpPr/>
+          <p:nvPr/>
+        </p:nvSpPr>
+        <p:spPr>
+          <a:xfrm>
+            <a:off x="6473952" y="4791456"/>
+            <a:ext cx="475488" cy="475488"/>
+          </a:xfrm>
+          <a:prstGeom prst="rect">
+            <a:avLst/>
+          </a:prstGeom>
+          <a:noFill/>
+          <a:ln/>
+        </p:spPr>
+        <p:txBody>
+          <a:bodyPr wrap="square" lIns="0" tIns="0" rIns="0" bIns="0" rtlCol="0" anchor="ctr"/>
+          <a:lstStyle/>
+          <a:p>
+            <a:pPr algn="ctr" indent="0" marL="0">
+              <a:buNone/>
+            </a:pPr>
+            <a:r>
+              <a:rPr lang="en-US" sz="1600" b="1" dirty="0">
+                <a:solidFill>
+                  <a:srgbClr val="FFFFFF"/>
+                </a:solidFill>
+                <a:latin typeface="Microsoft YaHei" pitchFamily="34" charset="0"/>
+                <a:ea typeface="Microsoft YaHei" pitchFamily="34" charset="-122"/>
+                <a:cs typeface="Microsoft YaHei" pitchFamily="34" charset="-120"/>
+              </a:rPr>
+              <a:t>6</a:t>
+            </a:r>
+            <a:endParaRPr lang="en-US" sz="1600" dirty="0"/>
+          </a:p>
+        </p:txBody>
+      </p:sp>
+      <p:sp>
+        <p:nvSpPr>
+          <p:cNvPr id="29" name="Text 27"/>
+          <p:cNvSpPr/>
+          <p:nvPr/>
+        </p:nvSpPr>
+        <p:spPr>
+          <a:xfrm>
+            <a:off x="7114032" y="4754880"/>
+            <a:ext cx="4572000" cy="1234440"/>
+          </a:xfrm>
+          <a:prstGeom prst="rect">
+            <a:avLst/>
+          </a:prstGeom>
+          <a:noFill/>
+          <a:ln/>
+        </p:spPr>
+        <p:txBody>
+          <a:bodyPr wrap="square" lIns="0" tIns="0" rIns="0" bIns="0" rtlCol="0" anchor="t"/>
+          <a:lstStyle/>
+          <a:p>
+            <a:pPr indent="0" marL="0">
+              <a:buNone/>
+            </a:pPr>
+            <a:r>
+              <a:rPr lang="en-US" sz="1400" b="1" dirty="0">
+                <a:solidFill>
+                  <a:srgbClr val="16233B"/>
+                </a:solidFill>
+                <a:latin typeface="Microsoft YaHei" pitchFamily="34" charset="0"/>
+                <a:ea typeface="Microsoft YaHei" pitchFamily="34" charset="-122"/>
+                <a:cs typeface="Microsoft YaHei" pitchFamily="34" charset="-120"/>
+              </a:rPr>
+              <a:t>跨平台纪律</a:t>
+            </a:r>
+            <a:endParaRPr lang="en-US" sz="1400" dirty="0"/>
+          </a:p>
+          <a:p>
+            <a:pPr indent="0" marL="0">
+              <a:buNone/>
+            </a:pPr>
+            <a:r>
+              <a:rPr lang="en-US" sz="1100" dirty="0">
+                <a:solidFill>
+                  <a:srgbClr val="63748A"/>
+                </a:solidFill>
+                <a:latin typeface="Microsoft YaHei" pitchFamily="34" charset="0"/>
+                <a:ea typeface="Microsoft YaHei" pitchFamily="34" charset="-122"/>
+                <a:cs typeface="Microsoft YaHei" pitchFamily="34" charset="-120"/>
+              </a:rPr>
+              <a:t>标准 C++ 单一路径（std::gmtime 等），禁止仅 Windows 的功能分支，仅允许告警抑制 pragma</a:t>
+            </a:r>
+            <a:endParaRPr lang="en-US" sz="1400" dirty="0"/>
           </a:p>
         </p:txBody>
       </p:sp>
@@ -11230,6 +11916,195 @@
               <a:t>既然没有现成的隔离加载机制，那就自己实现「同名程序集二次加载」—— 下一站：直接反复加载 Assembly</a:t>
             </a:r>
             <a:endParaRPr lang="en-US" sz="1350" dirty="0"/>
+          </a:p>
+        </p:txBody>
+      </p:sp>
+    </p:spTree>
+  </p:cSld>
+  <p:clrMapOvr>
+    <a:masterClrMapping/>
+  </p:clrMapOvr>
+</p:sld>
+</file>
+
+<file path=ppt/slides/slide20.xml><?xml version="1.0" encoding="utf-8"?>
+<p:sld xmlns:a="http://schemas.openxmlformats.org/drawingml/2006/main" xmlns:r="http://schemas.openxmlformats.org/officeDocument/2006/relationships" xmlns:p="http://schemas.openxmlformats.org/presentationml/2006/main">
+  <p:cSld name="Slide 20">
+    <p:bg>
+      <p:bgPr>
+        <a:solidFill>
+          <a:srgbClr val="16233B"/>
+        </a:solidFill>
+      </p:bgPr>
+    </p:bg>
+    <p:spTree>
+      <p:nvGrpSpPr>
+        <p:cNvPr id="1" name=""/>
+        <p:cNvGrpSpPr/>
+        <p:nvPr/>
+      </p:nvGrpSpPr>
+      <p:grpSpPr>
+        <a:xfrm>
+          <a:off x="0" y="0"/>
+          <a:ext cx="0" cy="0"/>
+          <a:chOff x="0" y="0"/>
+          <a:chExt cx="0" cy="0"/>
+        </a:xfrm>
+      </p:grpSpPr>
+      <p:sp>
+        <p:nvSpPr>
+          <p:cNvPr id="2" name="Shape 0"/>
+          <p:cNvSpPr/>
+          <p:nvPr/>
+        </p:nvSpPr>
+        <p:spPr>
+          <a:xfrm>
+            <a:off x="0" y="0"/>
+            <a:ext cx="12191695" cy="6858000"/>
+          </a:xfrm>
+          <a:prstGeom prst="rect">
+            <a:avLst/>
+          </a:prstGeom>
+          <a:solidFill>
+            <a:srgbClr val="16233B"/>
+          </a:solidFill>
+          <a:ln/>
+        </p:spPr>
+      </p:sp>
+      <p:sp>
+        <p:nvSpPr>
+          <p:cNvPr id="3" name="Shape 1"/>
+          <p:cNvSpPr/>
+          <p:nvPr/>
+        </p:nvSpPr>
+        <p:spPr>
+          <a:xfrm>
+            <a:off x="822960" y="2377440"/>
+            <a:ext cx="128016" cy="1554480"/>
+          </a:xfrm>
+          <a:prstGeom prst="rect">
+            <a:avLst/>
+          </a:prstGeom>
+          <a:solidFill>
+            <a:srgbClr val="0E9AA8"/>
+          </a:solidFill>
+          <a:ln/>
+        </p:spPr>
+      </p:sp>
+      <p:sp>
+        <p:nvSpPr>
+          <p:cNvPr id="4" name="Text 2"/>
+          <p:cNvSpPr/>
+          <p:nvPr/>
+        </p:nvSpPr>
+        <p:spPr>
+          <a:xfrm>
+            <a:off x="1143000" y="2331720"/>
+            <a:ext cx="10058400" cy="731520"/>
+          </a:xfrm>
+          <a:prstGeom prst="rect">
+            <a:avLst/>
+          </a:prstGeom>
+          <a:noFill/>
+          <a:ln/>
+        </p:spPr>
+        <p:txBody>
+          <a:bodyPr wrap="square" lIns="0" tIns="0" rIns="0" bIns="0" rtlCol="0" anchor="ctr"/>
+          <a:lstStyle/>
+          <a:p>
+            <a:pPr indent="0" marL="0">
+              <a:buNone/>
+            </a:pPr>
+            <a:r>
+              <a:rPr lang="en-US" sz="2800" b="1" dirty="0">
+                <a:solidFill>
+                  <a:srgbClr val="FFFFFF"/>
+                </a:solidFill>
+                <a:latin typeface="Microsoft YaHei" pitchFamily="34" charset="0"/>
+                <a:ea typeface="Microsoft YaHei" pitchFamily="34" charset="-122"/>
+                <a:cs typeface="Microsoft YaHei" pitchFamily="34" charset="-120"/>
+              </a:rPr>
+              <a:t>热重载的复杂度，是在为运行时内部一致性付账</a:t>
+            </a:r>
+            <a:endParaRPr lang="en-US" sz="2800" dirty="0"/>
+          </a:p>
+        </p:txBody>
+      </p:sp>
+      <p:sp>
+        <p:nvSpPr>
+          <p:cNvPr id="5" name="Text 3"/>
+          <p:cNvSpPr/>
+          <p:nvPr/>
+        </p:nvSpPr>
+        <p:spPr>
+          <a:xfrm>
+            <a:off x="1143000" y="3154680"/>
+            <a:ext cx="10058400" cy="457200"/>
+          </a:xfrm>
+          <a:prstGeom prst="rect">
+            <a:avLst/>
+          </a:prstGeom>
+          <a:noFill/>
+          <a:ln/>
+        </p:spPr>
+        <p:txBody>
+          <a:bodyPr wrap="square" lIns="0" tIns="0" rIns="0" bIns="0" rtlCol="0" anchor="ctr"/>
+          <a:lstStyle/>
+          <a:p>
+            <a:pPr indent="0" marL="0">
+              <a:buNone/>
+            </a:pPr>
+            <a:r>
+              <a:rPr lang="en-US" sz="1600" dirty="0">
+                <a:solidFill>
+                  <a:srgbClr val="9FB3C8"/>
+                </a:solidFill>
+                <a:latin typeface="Microsoft YaHei" pitchFamily="34" charset="0"/>
+                <a:ea typeface="Microsoft YaHei" pitchFamily="34" charset="-122"/>
+                <a:cs typeface="Microsoft YaHei" pitchFamily="34" charset="-120"/>
+              </a:rPr>
+              <a:t>复用不是目的，让三层指针身份唯一才是。</a:t>
+            </a:r>
+            <a:endParaRPr lang="en-US" sz="1600" dirty="0"/>
+          </a:p>
+        </p:txBody>
+      </p:sp>
+      <p:sp>
+        <p:nvSpPr>
+          <p:cNvPr id="6" name="Text 4"/>
+          <p:cNvSpPr/>
+          <p:nvPr/>
+        </p:nvSpPr>
+        <p:spPr>
+          <a:xfrm>
+            <a:off x="1143000" y="4206240"/>
+            <a:ext cx="5486400" cy="548640"/>
+          </a:xfrm>
+          <a:prstGeom prst="rect">
+            <a:avLst/>
+          </a:prstGeom>
+          <a:noFill/>
+          <a:ln/>
+        </p:spPr>
+        <p:txBody>
+          <a:bodyPr wrap="square" lIns="0" tIns="0" rIns="0" bIns="0" rtlCol="0" anchor="ctr"/>
+          <a:lstStyle/>
+          <a:p>
+            <a:pPr indent="0" marL="0">
+              <a:buNone/>
+            </a:pPr>
+            <a:r>
+              <a:rPr lang="en-US" sz="2000" b="1" dirty="0">
+                <a:solidFill>
+                  <a:srgbClr val="0E9AA8"/>
+                </a:solidFill>
+                <a:latin typeface="Microsoft YaHei" pitchFamily="34" charset="0"/>
+                <a:ea typeface="Microsoft YaHei" pitchFamily="34" charset="-122"/>
+                <a:cs typeface="Microsoft YaHei" pitchFamily="34" charset="-120"/>
+              </a:rPr>
+              <a:t>Q &amp; A</a:t>
+            </a:r>
+            <a:endParaRPr lang="en-US" sz="2000" dirty="0"/>
           </a:p>
         </p:txBody>
       </p:sp>

</xml_diff>